<commit_message>
Update VP readout PPTX with combined BIOS format
- BIOS 100% (282.0) + BIOS 50% (40.1) now shown as single "BIOS: 322.1 (67.4%)"
- 3 slides: Title, Recovery Summary with waterfall mockup, Step Breakdown
- Percentages shown in brackets next to DPM values per boss request
</commit_message>
<xml_diff>
--- a/Y6CP_cDPM_Recovery_VP_Readout_SOCAMM2_7500MT_WW0615.pptx
+++ b/Y6CP_cDPM_Recovery_VP_Readout_SOCAMM2_7500MT_WW0615.pptx
@@ -8,12 +8,6 @@
     <p:sldId id="256" r:id="rId7"/>
     <p:sldId id="257" r:id="rId8"/>
     <p:sldId id="258" r:id="rId9"/>
-    <p:sldId id="259" r:id="rId10"/>
-    <p:sldId id="260" r:id="rId11"/>
-    <p:sldId id="261" r:id="rId12"/>
-    <p:sldId id="262" r:id="rId13"/>
-    <p:sldId id="263" r:id="rId14"/>
-    <p:sldId id="264" r:id="rId15"/>
   </p:sldIdLst>
   <p:sldSz cx="12191695" cy="6858000" type="screen4x3"/>
   <p:notesSz cx="6858000" cy="9144000"/>
@@ -3111,7 +3105,7 @@
             <a:avLst/>
           </a:prstGeom>
           <a:solidFill>
-            <a:srgbClr val="003366"/>
+            <a:srgbClr val="1A237E"/>
           </a:solidFill>
           <a:ln>
             <a:noFill/>
@@ -3169,32 +3163,9 @@
               </a:defRPr>
             </a:pPr>
             <a:r>
-              <a:t>Y6CP cDPM Recovery Analysis</a:t>
-            </a:r>
-          </a:p>
-        </p:txBody>
-      </p:sp>
-      <p:sp>
-        <p:nvSpPr>
-          <p:cNvPr id="4" name="TextBox 3"/>
-          <p:cNvSpPr txBox="1"/>
-          <p:nvPr/>
-        </p:nvSpPr>
-        <p:spPr>
-          <a:xfrm>
-            <a:off x="457200" y="3840480"/>
-            <a:ext cx="11277295" cy="914400"/>
-          </a:xfrm>
-          <a:prstGeom prst="rect">
-            <a:avLst/>
-          </a:prstGeom>
-          <a:noFill/>
-        </p:spPr>
-        <p:txBody>
-          <a:bodyPr wrap="none">
-            <a:spAutoFit/>
-          </a:bodyPr>
-          <a:lstStyle/>
+              <a:t>SLT cDPM Recovery Analysis</a:t>
+            </a:r>
+          </a:p>
           <a:p>
             <a:pPr algn="ctr">
               <a:defRPr sz="2400">
@@ -3204,11 +3175,19 @@
               </a:defRPr>
             </a:pPr>
             <a:r>
-              <a:t>SOCAMM2 7500MT | WW202606-15 (10 Weeks)</a:t>
-            </a:r>
-            <a:br/>
-            <a:r>
-              <a:t>HMB1 &amp; QMON Steps</a:t>
+              <a:t>Y6CP SOCAMM2 7500MTPS | WW202606-202615</a:t>
+            </a:r>
+          </a:p>
+          <a:p>
+            <a:pPr algn="ctr">
+              <a:defRPr sz="1800">
+                <a:solidFill>
+                  <a:srgbClr val="969696"/>
+                </a:solidFill>
+              </a:defRPr>
+            </a:pPr>
+            <a:r>
+              <a:t>April 2026</a:t>
             </a:r>
           </a:p>
         </p:txBody>
@@ -3240,13 +3219,13 @@
         <p:spPr>
           <a:xfrm>
             <a:off x="0" y="0"/>
-            <a:ext cx="12191695" cy="822960"/>
+            <a:ext cx="12191695" cy="914400"/>
           </a:xfrm>
           <a:prstGeom prst="rect">
             <a:avLst/>
           </a:prstGeom>
           <a:solidFill>
-            <a:srgbClr val="003366"/>
+            <a:srgbClr val="1A237E"/>
           </a:solidFill>
           <a:ln>
             <a:noFill/>
@@ -3282,8 +3261,8 @@
         </p:nvSpPr>
         <p:spPr>
           <a:xfrm>
-            <a:off x="274320" y="182880"/>
-            <a:ext cx="11430000" cy="548640"/>
+            <a:off x="457200" y="228600"/>
+            <a:ext cx="10972800" cy="548640"/>
           </a:xfrm>
           <a:prstGeom prst="rect">
             <a:avLst/>
@@ -3304,127 +3283,27 @@
               </a:defRPr>
             </a:pPr>
             <a:r>
-              <a:t>Executive Summary</a:t>
-            </a:r>
-          </a:p>
-        </p:txBody>
-      </p:sp>
-      <p:sp>
-        <p:nvSpPr>
-          <p:cNvPr id="4" name="TextBox 3"/>
-          <p:cNvSpPr txBox="1"/>
+              <a:t>SLT cDPM Recovery Summary</a:t>
+            </a:r>
+          </a:p>
+        </p:txBody>
+      </p:sp>
+      <p:sp>
+        <p:nvSpPr>
+          <p:cNvPr id="4" name="Rounded Rectangle 3"/>
+          <p:cNvSpPr/>
           <p:nvPr/>
         </p:nvSpPr>
         <p:spPr>
           <a:xfrm>
-            <a:off x="457200" y="1097280"/>
-            <a:ext cx="11277295" cy="5486400"/>
+            <a:off x="457200" y="1188720"/>
+            <a:ext cx="2194560" cy="1097280"/>
           </a:xfrm>
-          <a:prstGeom prst="rect">
-            <a:avLst/>
-          </a:prstGeom>
-          <a:noFill/>
-        </p:spPr>
-        <p:txBody>
-          <a:bodyPr wrap="square">
-            <a:spAutoFit/>
-          </a:bodyPr>
-          <a:lstStyle/>
-          <a:p>
-            <a:pPr>
-              <a:defRPr sz="1600"/>
-            </a:pPr>
-            <a:r>
-              <a:t>Key Findings (SOCAMM2 7500MT, 10-Week Cumulative):</a:t>
-            </a:r>
-            <a:br/>
-            <a:br/>
-            <a:r>
-              <a:t>HMB1 Step:</a:t>
-            </a:r>
-            <a:br/>
-            <a:r>
-              <a:t>• Yield: 98.32% (29,788 modules tested)</a:t>
-            </a:r>
-            <a:br/>
-            <a:r>
-              <a:t>• Total cDPM: 265.7 → Customer-Facing: 98.6 DPM</a:t>
-            </a:r>
-            <a:br/>
-            <a:r>
-              <a:t>• Recovery: 167.2 DPM (63% recoverable)</a:t>
-            </a:r>
-            <a:br/>
-            <a:br/>
-            <a:r>
-              <a:t>QMON Step:</a:t>
-            </a:r>
-            <a:br/>
-            <a:r>
-              <a:t>• Yield: 98.79% (24,126 modules tested)</a:t>
-            </a:r>
-            <a:br/>
-            <a:r>
-              <a:t>• Total cDPM: 191.2 → Customer-Facing: 59.4 DPM</a:t>
-            </a:r>
-            <a:br/>
-            <a:r>
-              <a:t>• Recovery: 131.8 DPM (69% recoverable)</a:t>
-            </a:r>
-            <a:br/>
-            <a:br/>
-            <a:r>
-              <a:t>Combined SLT (HMB1 × QMON):</a:t>
-            </a:r>
-            <a:br/>
-            <a:r>
-              <a:t>• Combined Yield: 97.13%</a:t>
-            </a:r>
-            <a:br/>
-            <a:r>
-              <a:t>• Total cDPM: 456.9 → Customer-Facing: 157.9 DPM</a:t>
-            </a:r>
-            <a:br/>
-            <a:r>
-              <a:t>• Total Recoverable: 298.9 DPM (65%)</a:t>
-            </a:r>
-          </a:p>
-        </p:txBody>
-      </p:sp>
-    </p:spTree>
-  </p:cSld>
-  <p:clrMapOvr>
-    <a:masterClrMapping/>
-  </p:clrMapOvr>
-</p:sld>
-</file>
-
-<file path=ppt/slides/slide3.xml><?xml version="1.0" encoding="utf-8"?>
-<p:sld xmlns:a="http://schemas.openxmlformats.org/drawingml/2006/main" xmlns:p="http://schemas.openxmlformats.org/presentationml/2006/main" xmlns:r="http://schemas.openxmlformats.org/officeDocument/2006/relationships">
-  <p:cSld>
-    <p:spTree>
-      <p:nvGrpSpPr>
-        <p:cNvPr id="1" name=""/>
-        <p:cNvGrpSpPr/>
-        <p:nvPr/>
-      </p:nvGrpSpPr>
-      <p:grpSpPr/>
-      <p:sp>
-        <p:nvSpPr>
-          <p:cNvPr id="2" name="Rectangle 1"/>
-          <p:cNvSpPr/>
-          <p:nvPr/>
-        </p:nvSpPr>
-        <p:spPr>
-          <a:xfrm>
-            <a:off x="0" y="0"/>
-            <a:ext cx="12191695" cy="822960"/>
-          </a:xfrm>
-          <a:prstGeom prst="rect">
+          <a:prstGeom prst="roundRect">
             <a:avLst/>
           </a:prstGeom>
           <a:solidFill>
-            <a:srgbClr val="003366"/>
+            <a:srgbClr val="1A237E"/>
           </a:solidFill>
           <a:ln>
             <a:noFill/>
@@ -3454,14 +3333,14 @@
       </p:sp>
       <p:sp>
         <p:nvSpPr>
-          <p:cNvPr id="3" name="TextBox 2"/>
+          <p:cNvPr id="5" name="TextBox 4"/>
           <p:cNvSpPr txBox="1"/>
           <p:nvPr/>
         </p:nvSpPr>
         <p:spPr>
           <a:xfrm>
-            <a:off x="274320" y="182880"/>
-            <a:ext cx="11430000" cy="548640"/>
+            <a:off x="457200" y="1371600"/>
+            <a:ext cx="2194560" cy="457200"/>
           </a:xfrm>
           <a:prstGeom prst="rect">
             <a:avLst/>
@@ -3474,571 +3353,29 @@
           </a:bodyPr>
           <a:lstStyle/>
           <a:p>
-            <a:pPr>
-              <a:defRPr sz="2800" b="1">
+            <a:pPr algn="ctr">
+              <a:defRPr sz="2400" b="1">
                 <a:solidFill>
                   <a:srgbClr val="FFFFFF"/>
                 </a:solidFill>
               </a:defRPr>
             </a:pPr>
             <a:r>
-              <a:t>MFG vs ENG View: Bridging the Communication Gap</a:t>
-            </a:r>
-          </a:p>
-        </p:txBody>
-      </p:sp>
-      <p:graphicFrame>
-        <p:nvGraphicFramePr>
-          <p:cNvPr id="4" name="Table 3"/>
-          <p:cNvGraphicFramePr>
-            <a:graphicFrameLocks noGrp="1"/>
-          </p:cNvGraphicFramePr>
-          <p:nvPr/>
-        </p:nvGraphicFramePr>
-        <p:xfrm>
-          <a:off x="1371600" y="1188720"/>
-          <a:ext cx="9144000" cy="2560320"/>
-        </p:xfrm>
-        <a:graphic>
-          <a:graphicData uri="http://schemas.openxmlformats.org/drawingml/2006/table">
-            <a:tbl>
-              <a:tblPr firstRow="1" bandRow="1">
-                <a:tableStyleId>{5C22544A-7EE6-4342-B048-85BDC9FD1C3A}</a:tableStyleId>
-              </a:tblPr>
-              <a:tblGrid>
-                <a:gridCol w="2286000"/>
-                <a:gridCol w="2286000"/>
-                <a:gridCol w="2286000"/>
-                <a:gridCol w="2286000"/>
-              </a:tblGrid>
-              <a:tr h="365760">
-                <a:tc>
-                  <a:txBody>
-                    <a:bodyPr/>
-                    <a:lstStyle/>
-                    <a:p>
-                      <a:pPr algn="ctr">
-                        <a:defRPr sz="1400" b="1">
-                          <a:solidFill>
-                            <a:srgbClr val="FFFFFF"/>
-                          </a:solidFill>
-                        </a:defRPr>
-                      </a:pPr>
-                      <a:r>
-                        <a:t>Metric</a:t>
-                      </a:r>
-                    </a:p>
-                  </a:txBody>
-                  <a:tcPr>
-                    <a:solidFill>
-                      <a:srgbClr val="003366"/>
-                    </a:solidFill>
-                  </a:tcPr>
-                </a:tc>
-                <a:tc>
-                  <a:txBody>
-                    <a:bodyPr/>
-                    <a:lstStyle/>
-                    <a:p>
-                      <a:pPr algn="ctr">
-                        <a:defRPr sz="1400" b="1">
-                          <a:solidFill>
-                            <a:srgbClr val="FFFFFF"/>
-                          </a:solidFill>
-                        </a:defRPr>
-                      </a:pPr>
-                      <a:r>
-                        <a:t>HMB1</a:t>
-                      </a:r>
-                    </a:p>
-                  </a:txBody>
-                  <a:tcPr>
-                    <a:solidFill>
-                      <a:srgbClr val="003366"/>
-                    </a:solidFill>
-                  </a:tcPr>
-                </a:tc>
-                <a:tc>
-                  <a:txBody>
-                    <a:bodyPr/>
-                    <a:lstStyle/>
-                    <a:p>
-                      <a:pPr algn="ctr">
-                        <a:defRPr sz="1400" b="1">
-                          <a:solidFill>
-                            <a:srgbClr val="FFFFFF"/>
-                          </a:solidFill>
-                        </a:defRPr>
-                      </a:pPr>
-                      <a:r>
-                        <a:t>QMON</a:t>
-                      </a:r>
-                    </a:p>
-                  </a:txBody>
-                  <a:tcPr>
-                    <a:solidFill>
-                      <a:srgbClr val="003366"/>
-                    </a:solidFill>
-                  </a:tcPr>
-                </a:tc>
-                <a:tc>
-                  <a:txBody>
-                    <a:bodyPr/>
-                    <a:lstStyle/>
-                    <a:p>
-                      <a:pPr algn="ctr">
-                        <a:defRPr sz="1400" b="1">
-                          <a:solidFill>
-                            <a:srgbClr val="FFFFFF"/>
-                          </a:solidFill>
-                        </a:defRPr>
-                      </a:pPr>
-                      <a:r>
-                        <a:t>Combined SLT</a:t>
-                      </a:r>
-                    </a:p>
-                  </a:txBody>
-                  <a:tcPr>
-                    <a:solidFill>
-                      <a:srgbClr val="003366"/>
-                    </a:solidFill>
-                  </a:tcPr>
-                </a:tc>
-              </a:tr>
-              <a:tr h="365760">
-                <a:tc>
-                  <a:txBody>
-                    <a:bodyPr/>
-                    <a:lstStyle/>
-                    <a:p>
-                      <a:pPr algn="ctr">
-                        <a:defRPr sz="1400" b="1"/>
-                      </a:pPr>
-                      <a:r>
-                        <a:t>MFG View (Yield %)</a:t>
-                      </a:r>
-                    </a:p>
-                  </a:txBody>
-                  <a:tcPr>
-                    <a:solidFill>
-                      <a:srgbClr val="C6E0B4"/>
-                    </a:solidFill>
-                  </a:tcPr>
-                </a:tc>
-                <a:tc>
-                  <a:txBody>
-                    <a:bodyPr/>
-                    <a:lstStyle/>
-                    <a:p>
-                      <a:pPr algn="ctr">
-                        <a:defRPr sz="1400" b="1"/>
-                      </a:pPr>
-                      <a:r>
-                        <a:t>98.32%</a:t>
-                      </a:r>
-                    </a:p>
-                  </a:txBody>
-                  <a:tcPr>
-                    <a:solidFill>
-                      <a:srgbClr val="C6E0B4"/>
-                    </a:solidFill>
-                  </a:tcPr>
-                </a:tc>
-                <a:tc>
-                  <a:txBody>
-                    <a:bodyPr/>
-                    <a:lstStyle/>
-                    <a:p>
-                      <a:pPr algn="ctr">
-                        <a:defRPr sz="1400" b="1"/>
-                      </a:pPr>
-                      <a:r>
-                        <a:t>98.79%</a:t>
-                      </a:r>
-                    </a:p>
-                  </a:txBody>
-                  <a:tcPr>
-                    <a:solidFill>
-                      <a:srgbClr val="C6E0B4"/>
-                    </a:solidFill>
-                  </a:tcPr>
-                </a:tc>
-                <a:tc>
-                  <a:txBody>
-                    <a:bodyPr/>
-                    <a:lstStyle/>
-                    <a:p>
-                      <a:pPr algn="ctr">
-                        <a:defRPr sz="1400" b="1"/>
-                      </a:pPr>
-                      <a:r>
-                        <a:t>97.13%</a:t>
-                      </a:r>
-                    </a:p>
-                  </a:txBody>
-                  <a:tcPr>
-                    <a:solidFill>
-                      <a:srgbClr val="C6E0B4"/>
-                    </a:solidFill>
-                  </a:tcPr>
-                </a:tc>
-              </a:tr>
-              <a:tr h="365760">
-                <a:tc>
-                  <a:txBody>
-                    <a:bodyPr/>
-                    <a:lstStyle/>
-                    <a:p>
-                      <a:pPr algn="ctr">
-                        <a:defRPr sz="1400"/>
-                      </a:pPr>
-                      <a:r>
-                        <a:t>Modules Tested</a:t>
-                      </a:r>
-                    </a:p>
-                  </a:txBody>
-                  <a:tcPr/>
-                </a:tc>
-                <a:tc>
-                  <a:txBody>
-                    <a:bodyPr/>
-                    <a:lstStyle/>
-                    <a:p>
-                      <a:pPr algn="ctr">
-                        <a:defRPr sz="1400"/>
-                      </a:pPr>
-                      <a:r>
-                        <a:t>29,788</a:t>
-                      </a:r>
-                    </a:p>
-                  </a:txBody>
-                  <a:tcPr/>
-                </a:tc>
-                <a:tc>
-                  <a:txBody>
-                    <a:bodyPr/>
-                    <a:lstStyle/>
-                    <a:p>
-                      <a:pPr algn="ctr">
-                        <a:defRPr sz="1400"/>
-                      </a:pPr>
-                      <a:r>
-                        <a:t>24,126</a:t>
-                      </a:r>
-                    </a:p>
-                  </a:txBody>
-                  <a:tcPr/>
-                </a:tc>
-                <a:tc>
-                  <a:txBody>
-                    <a:bodyPr/>
-                    <a:lstStyle/>
-                    <a:p>
-                      <a:pPr algn="ctr">
-                        <a:defRPr sz="1400"/>
-                      </a:pPr>
-                      <a:r>
-                        <a:t>-</a:t>
-                      </a:r>
-                    </a:p>
-                  </a:txBody>
-                  <a:tcPr/>
-                </a:tc>
-              </a:tr>
-              <a:tr h="365760">
-                <a:tc>
-                  <a:txBody>
-                    <a:bodyPr/>
-                    <a:lstStyle/>
-                    <a:p>
-                      <a:pPr algn="ctr">
-                        <a:defRPr sz="1400"/>
-                      </a:pPr>
-                      <a:r>
-                        <a:t>Modules Failed</a:t>
-                      </a:r>
-                    </a:p>
-                  </a:txBody>
-                  <a:tcPr/>
-                </a:tc>
-                <a:tc>
-                  <a:txBody>
-                    <a:bodyPr/>
-                    <a:lstStyle/>
-                    <a:p>
-                      <a:pPr algn="ctr">
-                        <a:defRPr sz="1400"/>
-                      </a:pPr>
-                      <a:r>
-                        <a:t>500</a:t>
-                      </a:r>
-                    </a:p>
-                  </a:txBody>
-                  <a:tcPr/>
-                </a:tc>
-                <a:tc>
-                  <a:txBody>
-                    <a:bodyPr/>
-                    <a:lstStyle/>
-                    <a:p>
-                      <a:pPr algn="ctr">
-                        <a:defRPr sz="1400"/>
-                      </a:pPr>
-                      <a:r>
-                        <a:t>292</a:t>
-                      </a:r>
-                    </a:p>
-                  </a:txBody>
-                  <a:tcPr/>
-                </a:tc>
-                <a:tc>
-                  <a:txBody>
-                    <a:bodyPr/>
-                    <a:lstStyle/>
-                    <a:p>
-                      <a:pPr algn="ctr">
-                        <a:defRPr sz="1400"/>
-                      </a:pPr>
-                      <a:r>
-                        <a:t>792</a:t>
-                      </a:r>
-                    </a:p>
-                  </a:txBody>
-                  <a:tcPr/>
-                </a:tc>
-              </a:tr>
-              <a:tr h="365760">
-                <a:tc>
-                  <a:txBody>
-                    <a:bodyPr/>
-                    <a:lstStyle/>
-                    <a:p>
-                      <a:pPr algn="ctr">
-                        <a:defRPr sz="1400" b="1"/>
-                      </a:pPr>
-                      <a:r>
-                        <a:t>ENG View (cDPM)</a:t>
-                      </a:r>
-                    </a:p>
-                  </a:txBody>
-                  <a:tcPr>
-                    <a:solidFill>
-                      <a:srgbClr val="FFC7CE"/>
-                    </a:solidFill>
-                  </a:tcPr>
-                </a:tc>
-                <a:tc>
-                  <a:txBody>
-                    <a:bodyPr/>
-                    <a:lstStyle/>
-                    <a:p>
-                      <a:pPr algn="ctr">
-                        <a:defRPr sz="1400" b="1"/>
-                      </a:pPr>
-                      <a:r>
-                        <a:t>265.7</a:t>
-                      </a:r>
-                    </a:p>
-                  </a:txBody>
-                  <a:tcPr>
-                    <a:solidFill>
-                      <a:srgbClr val="FFC7CE"/>
-                    </a:solidFill>
-                  </a:tcPr>
-                </a:tc>
-                <a:tc>
-                  <a:txBody>
-                    <a:bodyPr/>
-                    <a:lstStyle/>
-                    <a:p>
-                      <a:pPr algn="ctr">
-                        <a:defRPr sz="1400" b="1"/>
-                      </a:pPr>
-                      <a:r>
-                        <a:t>191.2</a:t>
-                      </a:r>
-                    </a:p>
-                  </a:txBody>
-                  <a:tcPr>
-                    <a:solidFill>
-                      <a:srgbClr val="FFC7CE"/>
-                    </a:solidFill>
-                  </a:tcPr>
-                </a:tc>
-                <a:tc>
-                  <a:txBody>
-                    <a:bodyPr/>
-                    <a:lstStyle/>
-                    <a:p>
-                      <a:pPr algn="ctr">
-                        <a:defRPr sz="1400" b="1"/>
-                      </a:pPr>
-                      <a:r>
-                        <a:t>456.9</a:t>
-                      </a:r>
-                    </a:p>
-                  </a:txBody>
-                  <a:tcPr>
-                    <a:solidFill>
-                      <a:srgbClr val="FFC7CE"/>
-                    </a:solidFill>
-                  </a:tcPr>
-                </a:tc>
-              </a:tr>
-              <a:tr h="365760">
-                <a:tc>
-                  <a:txBody>
-                    <a:bodyPr/>
-                    <a:lstStyle/>
-                    <a:p>
-                      <a:pPr algn="ctr">
-                        <a:defRPr sz="1400"/>
-                      </a:pPr>
-                      <a:r>
-                        <a:t>Recoverable DPM</a:t>
-                      </a:r>
-                    </a:p>
-                  </a:txBody>
-                  <a:tcPr/>
-                </a:tc>
-                <a:tc>
-                  <a:txBody>
-                    <a:bodyPr/>
-                    <a:lstStyle/>
-                    <a:p>
-                      <a:pPr algn="ctr">
-                        <a:defRPr sz="1400"/>
-                      </a:pPr>
-                      <a:r>
-                        <a:t>167.2</a:t>
-                      </a:r>
-                    </a:p>
-                  </a:txBody>
-                  <a:tcPr/>
-                </a:tc>
-                <a:tc>
-                  <a:txBody>
-                    <a:bodyPr/>
-                    <a:lstStyle/>
-                    <a:p>
-                      <a:pPr algn="ctr">
-                        <a:defRPr sz="1400"/>
-                      </a:pPr>
-                      <a:r>
-                        <a:t>131.8</a:t>
-                      </a:r>
-                    </a:p>
-                  </a:txBody>
-                  <a:tcPr/>
-                </a:tc>
-                <a:tc>
-                  <a:txBody>
-                    <a:bodyPr/>
-                    <a:lstStyle/>
-                    <a:p>
-                      <a:pPr algn="ctr">
-                        <a:defRPr sz="1400"/>
-                      </a:pPr>
-                      <a:r>
-                        <a:t>298.9</a:t>
-                      </a:r>
-                    </a:p>
-                  </a:txBody>
-                  <a:tcPr/>
-                </a:tc>
-              </a:tr>
-              <a:tr h="365760">
-                <a:tc>
-                  <a:txBody>
-                    <a:bodyPr/>
-                    <a:lstStyle/>
-                    <a:p>
-                      <a:pPr algn="ctr">
-                        <a:defRPr sz="1400" b="1"/>
-                      </a:pPr>
-                      <a:r>
-                        <a:t>Customer-Facing DPM</a:t>
-                      </a:r>
-                    </a:p>
-                  </a:txBody>
-                  <a:tcPr>
-                    <a:solidFill>
-                      <a:srgbClr val="FFEB9C"/>
-                    </a:solidFill>
-                  </a:tcPr>
-                </a:tc>
-                <a:tc>
-                  <a:txBody>
-                    <a:bodyPr/>
-                    <a:lstStyle/>
-                    <a:p>
-                      <a:pPr algn="ctr">
-                        <a:defRPr sz="1400" b="1"/>
-                      </a:pPr>
-                      <a:r>
-                        <a:t>98.6</a:t>
-                      </a:r>
-                    </a:p>
-                  </a:txBody>
-                  <a:tcPr>
-                    <a:solidFill>
-                      <a:srgbClr val="FFEB9C"/>
-                    </a:solidFill>
-                  </a:tcPr>
-                </a:tc>
-                <a:tc>
-                  <a:txBody>
-                    <a:bodyPr/>
-                    <a:lstStyle/>
-                    <a:p>
-                      <a:pPr algn="ctr">
-                        <a:defRPr sz="1400" b="1"/>
-                      </a:pPr>
-                      <a:r>
-                        <a:t>59.4</a:t>
-                      </a:r>
-                    </a:p>
-                  </a:txBody>
-                  <a:tcPr>
-                    <a:solidFill>
-                      <a:srgbClr val="FFEB9C"/>
-                    </a:solidFill>
-                  </a:tcPr>
-                </a:tc>
-                <a:tc>
-                  <a:txBody>
-                    <a:bodyPr/>
-                    <a:lstStyle/>
-                    <a:p>
-                      <a:pPr algn="ctr">
-                        <a:defRPr sz="1400" b="1"/>
-                      </a:pPr>
-                      <a:r>
-                        <a:t>157.9</a:t>
-                      </a:r>
-                    </a:p>
-                  </a:txBody>
-                  <a:tcPr>
-                    <a:solidFill>
-                      <a:srgbClr val="FFEB9C"/>
-                    </a:solidFill>
-                  </a:tcPr>
-                </a:tc>
-              </a:tr>
-            </a:tbl>
-          </a:graphicData>
-        </a:graphic>
-      </p:graphicFrame>
-      <p:sp>
-        <p:nvSpPr>
-          <p:cNvPr id="5" name="TextBox 4"/>
+              <a:t>478.0</a:t>
+            </a:r>
+          </a:p>
+        </p:txBody>
+      </p:sp>
+      <p:sp>
+        <p:nvSpPr>
+          <p:cNvPr id="6" name="TextBox 5"/>
           <p:cNvSpPr txBox="1"/>
           <p:nvPr/>
         </p:nvSpPr>
         <p:spPr>
           <a:xfrm>
-            <a:off x="457200" y="4114800"/>
-            <a:ext cx="11277295" cy="1371600"/>
+            <a:off x="457200" y="1828800"/>
+            <a:ext cx="2194560" cy="365760"/>
           </a:xfrm>
           <a:prstGeom prst="rect">
             <a:avLst/>
@@ -4046,62 +3383,40 @@
           <a:noFill/>
         </p:spPr>
         <p:txBody>
-          <a:bodyPr wrap="square">
+          <a:bodyPr wrap="none">
             <a:spAutoFit/>
           </a:bodyPr>
           <a:lstStyle/>
           <a:p>
-            <a:pPr>
-              <a:defRPr sz="1600" b="1"/>
+            <a:pPr algn="ctr">
+              <a:defRPr sz="1200">
+                <a:solidFill>
+                  <a:srgbClr val="FFFFFF"/>
+                </a:solidFill>
+              </a:defRPr>
             </a:pPr>
             <a:r>
-              <a:t>Key Message:</a:t>
-            </a:r>
-            <a:br/>
-            <a:r>
-              <a:t>MFG sees 97.1% yield (meeting shipping targets), but ENG sees 456.9 cDPM total risk.</a:t>
-            </a:r>
-            <a:br/>
-            <a:r>
-              <a:t>Through BIOS/HW+SOP recovery mechanisms, we reduce customer-facing risk to 157.9 cDPM.</a:t>
-            </a:r>
-          </a:p>
-        </p:txBody>
-      </p:sp>
-    </p:spTree>
-  </p:cSld>
-  <p:clrMapOvr>
-    <a:masterClrMapping/>
-  </p:clrMapOvr>
-</p:sld>
-</file>
-
-<file path=ppt/slides/slide4.xml><?xml version="1.0" encoding="utf-8"?>
-<p:sld xmlns:a="http://schemas.openxmlformats.org/drawingml/2006/main" xmlns:p="http://schemas.openxmlformats.org/presentationml/2006/main" xmlns:r="http://schemas.openxmlformats.org/officeDocument/2006/relationships">
-  <p:cSld>
-    <p:spTree>
-      <p:nvGrpSpPr>
-        <p:cNvPr id="1" name=""/>
-        <p:cNvGrpSpPr/>
-        <p:nvPr/>
-      </p:nvGrpSpPr>
-      <p:grpSpPr/>
-      <p:sp>
-        <p:nvSpPr>
-          <p:cNvPr id="2" name="Rectangle 1"/>
+              <a:t>Total SLT DPM</a:t>
+            </a:r>
+          </a:p>
+        </p:txBody>
+      </p:sp>
+      <p:sp>
+        <p:nvSpPr>
+          <p:cNvPr id="7" name="Rounded Rectangle 6"/>
           <p:cNvSpPr/>
           <p:nvPr/>
         </p:nvSpPr>
         <p:spPr>
           <a:xfrm>
-            <a:off x="0" y="0"/>
-            <a:ext cx="12191695" cy="822960"/>
+            <a:off x="2788920" y="1188720"/>
+            <a:ext cx="2194560" cy="1097280"/>
           </a:xfrm>
-          <a:prstGeom prst="rect">
+          <a:prstGeom prst="roundRect">
             <a:avLst/>
           </a:prstGeom>
           <a:solidFill>
-            <a:srgbClr val="003366"/>
+            <a:srgbClr val="1976D2"/>
           </a:solidFill>
           <a:ln>
             <a:noFill/>
@@ -4131,14 +3446,14 @@
       </p:sp>
       <p:sp>
         <p:nvSpPr>
-          <p:cNvPr id="3" name="TextBox 2"/>
+          <p:cNvPr id="8" name="TextBox 7"/>
           <p:cNvSpPr txBox="1"/>
           <p:nvPr/>
         </p:nvSpPr>
         <p:spPr>
           <a:xfrm>
-            <a:off x="274320" y="182880"/>
-            <a:ext cx="11430000" cy="548640"/>
+            <a:off x="2788920" y="1371600"/>
+            <a:ext cx="2194560" cy="457200"/>
           </a:xfrm>
           <a:prstGeom prst="rect">
             <a:avLst/>
@@ -4151,29 +3466,29 @@
           </a:bodyPr>
           <a:lstStyle/>
           <a:p>
-            <a:pPr>
-              <a:defRPr sz="2800" b="1">
+            <a:pPr algn="ctr">
+              <a:defRPr sz="2400" b="1">
                 <a:solidFill>
                   <a:srgbClr val="FFFFFF"/>
                 </a:solidFill>
               </a:defRPr>
             </a:pPr>
             <a:r>
-              <a:t>DPM Calculation: Kevin Roos Method</a:t>
-            </a:r>
-          </a:p>
-        </p:txBody>
-      </p:sp>
-      <p:sp>
-        <p:nvSpPr>
-          <p:cNvPr id="4" name="TextBox 3"/>
+              <a:t>322.1 (67.4%)</a:t>
+            </a:r>
+          </a:p>
+        </p:txBody>
+      </p:sp>
+      <p:sp>
+        <p:nvSpPr>
+          <p:cNvPr id="9" name="TextBox 8"/>
           <p:cNvSpPr txBox="1"/>
           <p:nvPr/>
         </p:nvSpPr>
         <p:spPr>
           <a:xfrm>
-            <a:off x="457200" y="1005840"/>
-            <a:ext cx="11277295" cy="5486400"/>
+            <a:off x="2788920" y="1828800"/>
+            <a:ext cx="2194560" cy="365760"/>
           </a:xfrm>
           <a:prstGeom prst="rect">
             <a:avLst/>
@@ -4181,116 +3496,40 @@
           <a:noFill/>
         </p:spPr>
         <p:txBody>
-          <a:bodyPr wrap="square">
+          <a:bodyPr wrap="none">
             <a:spAutoFit/>
           </a:bodyPr>
           <a:lstStyle/>
           <a:p>
-            <a:pPr>
-              <a:defRPr sz="1400">
-                <a:latin typeface="Consolas"/>
+            <a:pPr algn="ctr">
+              <a:defRPr sz="1200">
+                <a:solidFill>
+                  <a:srgbClr val="FFFFFF"/>
+                </a:solidFill>
               </a:defRPr>
             </a:pPr>
             <a:r>
-              <a:t>Formula:</a:t>
-            </a:r>
-            <a:br/>
-            <a:r>
-              <a:t>                    Unique Failing MSNs</a:t>
-            </a:r>
-            <a:br/>
-            <a:r>
-              <a:t>        cDPM = ─────────────────────────── × 1,000,000</a:t>
-            </a:r>
-            <a:br/>
-            <a:r>
-              <a:t>                      Total FID UIN</a:t>
-            </a:r>
-            <a:br/>
-            <a:br/>
-            <a:r>
-              <a:t>Calculation:</a:t>
-            </a:r>
-            <a:br/>
-            <a:br/>
-            <a:r>
-              <a:t>HMB1:</a:t>
-            </a:r>
-            <a:br/>
-            <a:r>
-              <a:t>    cDPM = 500 unique failing modules / 1,881,631 total FIDs × 1,000,000</a:t>
-            </a:r>
-            <a:br/>
-            <a:r>
-              <a:t>         = 265.73 DPM</a:t>
-            </a:r>
-            <a:br/>
-            <a:br/>
-            <a:r>
-              <a:t>QMON:</a:t>
-            </a:r>
-            <a:br/>
-            <a:r>
-              <a:t>    cDPM = 292 unique failing modules / 1,527,576 total FIDs × 1,000,000</a:t>
-            </a:r>
-            <a:br/>
-            <a:r>
-              <a:t>         = 191.15 DPM</a:t>
-            </a:r>
-            <a:br/>
-            <a:br/>
-            <a:r>
-              <a:t>Key Points:</a:t>
-            </a:r>
-            <a:br/>
-            <a:r>
-              <a:t>• Numerator: Count of unique MSNs (modules) with failures - each module counted ONCE</a:t>
-            </a:r>
-            <a:br/>
-            <a:r>
-              <a:t>• Denominator: Total FID UIN (component population) from mtsums +fidag</a:t>
-            </a:r>
-            <a:br/>
-            <a:r>
-              <a:t>• This gives component-level perspective while counting module-level failures</a:t>
-            </a:r>
-          </a:p>
-        </p:txBody>
-      </p:sp>
-    </p:spTree>
-  </p:cSld>
-  <p:clrMapOvr>
-    <a:masterClrMapping/>
-  </p:clrMapOvr>
-</p:sld>
-</file>
-
-<file path=ppt/slides/slide5.xml><?xml version="1.0" encoding="utf-8"?>
-<p:sld xmlns:a="http://schemas.openxmlformats.org/drawingml/2006/main" xmlns:p="http://schemas.openxmlformats.org/presentationml/2006/main" xmlns:r="http://schemas.openxmlformats.org/officeDocument/2006/relationships">
-  <p:cSld>
-    <p:spTree>
-      <p:nvGrpSpPr>
-        <p:cNvPr id="1" name=""/>
-        <p:cNvGrpSpPr/>
-        <p:nvPr/>
-      </p:nvGrpSpPr>
-      <p:grpSpPr/>
-      <p:sp>
-        <p:nvSpPr>
-          <p:cNvPr id="2" name="Rectangle 1"/>
+              <a:t>BIOS Recovery</a:t>
+            </a:r>
+          </a:p>
+        </p:txBody>
+      </p:sp>
+      <p:sp>
+        <p:nvSpPr>
+          <p:cNvPr id="10" name="Rounded Rectangle 9"/>
           <p:cNvSpPr/>
           <p:nvPr/>
         </p:nvSpPr>
         <p:spPr>
           <a:xfrm>
-            <a:off x="0" y="0"/>
-            <a:ext cx="12191695" cy="822960"/>
+            <a:off x="5120640" y="1188720"/>
+            <a:ext cx="2194560" cy="1097280"/>
           </a:xfrm>
-          <a:prstGeom prst="rect">
+          <a:prstGeom prst="roundRect">
             <a:avLst/>
           </a:prstGeom>
           <a:solidFill>
-            <a:srgbClr val="003366"/>
+            <a:srgbClr val="C2185B"/>
           </a:solidFill>
           <a:ln>
             <a:noFill/>
@@ -4320,14 +3559,14 @@
       </p:sp>
       <p:sp>
         <p:nvSpPr>
-          <p:cNvPr id="3" name="TextBox 2"/>
+          <p:cNvPr id="11" name="TextBox 10"/>
           <p:cNvSpPr txBox="1"/>
           <p:nvPr/>
         </p:nvSpPr>
         <p:spPr>
           <a:xfrm>
-            <a:off x="274320" y="182880"/>
-            <a:ext cx="11430000" cy="548640"/>
+            <a:off x="5120640" y="1371600"/>
+            <a:ext cx="2194560" cy="457200"/>
           </a:xfrm>
           <a:prstGeom prst="rect">
             <a:avLst/>
@@ -4340,29 +3579,29 @@
           </a:bodyPr>
           <a:lstStyle/>
           <a:p>
-            <a:pPr>
-              <a:defRPr sz="2800" b="1">
+            <a:pPr algn="ctr">
+              <a:defRPr sz="2400" b="1">
                 <a:solidFill>
                   <a:srgbClr val="FFFFFF"/>
                 </a:solidFill>
               </a:defRPr>
             </a:pPr>
             <a:r>
-              <a:t>Top FAILCRAWLER Categories by DPM</a:t>
-            </a:r>
-          </a:p>
-        </p:txBody>
-      </p:sp>
-      <p:sp>
-        <p:nvSpPr>
-          <p:cNvPr id="4" name="TextBox 3"/>
+              <a:t>19.3 (4.0%)</a:t>
+            </a:r>
+          </a:p>
+        </p:txBody>
+      </p:sp>
+      <p:sp>
+        <p:nvSpPr>
+          <p:cNvPr id="12" name="TextBox 11"/>
           <p:cNvSpPr txBox="1"/>
           <p:nvPr/>
         </p:nvSpPr>
         <p:spPr>
           <a:xfrm>
-            <a:off x="457200" y="1097280"/>
-            <a:ext cx="5486400" cy="4572000"/>
+            <a:off x="5120640" y="1828800"/>
+            <a:ext cx="2194560" cy="365760"/>
           </a:xfrm>
           <a:prstGeom prst="rect">
             <a:avLst/>
@@ -4370,157 +3609,40 @@
           <a:noFill/>
         </p:spPr>
         <p:txBody>
-          <a:bodyPr wrap="square">
+          <a:bodyPr wrap="none">
             <a:spAutoFit/>
           </a:bodyPr>
           <a:lstStyle/>
           <a:p>
-            <a:pPr>
-              <a:defRPr sz="1300"/>
+            <a:pPr algn="ctr">
+              <a:defRPr sz="1200">
+                <a:solidFill>
+                  <a:srgbClr val="FFFFFF"/>
+                </a:solidFill>
+              </a:defRPr>
             </a:pPr>
             <a:r>
-              <a:t>HMB1 (Total: 265.7 DPM)</a:t>
-            </a:r>
-            <a:br/>
-            <a:r>
-              <a:t>───────────────────────────────────</a:t>
-            </a:r>
-            <a:br/>
-            <a:r>
-              <a:t>• MULTI_BANK_MULTI_DQ: 98.0 DPM (37%)</a:t>
-            </a:r>
-            <a:br/>
-            <a:r>
-              <a:t>• SINGLE_BURST_SINGLE_ROW: 46.3 DPM (17%)</a:t>
-            </a:r>
-            <a:br/>
-            <a:r>
-              <a:t>• HGDC: 41.6 DPM (16%)</a:t>
-            </a:r>
-            <a:br/>
-            <a:r>
-              <a:t>• HANG: 15.9 DPM (6%)</a:t>
-            </a:r>
-            <a:br/>
-            <a:r>
-              <a:t>• SYS_EVEN_BURST_BIT: 12.8 DPM (5%)</a:t>
-            </a:r>
-            <a:br/>
-            <a:r>
-              <a:t>• MULTI_HALFBANK_SINGLE_DQ: 8.7 DPM (3%)</a:t>
-            </a:r>
-            <a:br/>
-            <a:r>
-              <a:t>• UNKNOWN: 7.4 DPM (3%)</a:t>
-            </a:r>
-            <a:br/>
-            <a:r>
-              <a:t>• MULTI_HALFBANK_MULTI_DQ: 6.2 DPM (2%)</a:t>
-            </a:r>
-          </a:p>
-        </p:txBody>
-      </p:sp>
-      <p:sp>
-        <p:nvSpPr>
-          <p:cNvPr id="5" name="TextBox 4"/>
-          <p:cNvSpPr txBox="1"/>
+              <a:t>HW+SOP</a:t>
+            </a:r>
+          </a:p>
+        </p:txBody>
+      </p:sp>
+      <p:sp>
+        <p:nvSpPr>
+          <p:cNvPr id="13" name="Rounded Rectangle 12"/>
+          <p:cNvSpPr/>
           <p:nvPr/>
         </p:nvSpPr>
         <p:spPr>
           <a:xfrm>
-            <a:off x="6217920" y="1097280"/>
-            <a:ext cx="5486400" cy="4572000"/>
+            <a:off x="7452360" y="1188720"/>
+            <a:ext cx="2194560" cy="1097280"/>
           </a:xfrm>
-          <a:prstGeom prst="rect">
-            <a:avLst/>
-          </a:prstGeom>
-          <a:noFill/>
-        </p:spPr>
-        <p:txBody>
-          <a:bodyPr wrap="square">
-            <a:spAutoFit/>
-          </a:bodyPr>
-          <a:lstStyle/>
-          <a:p>
-            <a:pPr>
-              <a:defRPr sz="1300"/>
-            </a:pPr>
-            <a:r>
-              <a:t>QMON (Total: 191.2 DPM)</a:t>
-            </a:r>
-            <a:br/>
-            <a:r>
-              <a:t>───────────────────────────────────</a:t>
-            </a:r>
-            <a:br/>
-            <a:r>
-              <a:t>• MULTI_BANK_MULTI_DQ: 105.5 DPM (55%)</a:t>
-            </a:r>
-            <a:br/>
-            <a:r>
-              <a:t>• SINGLE_BURST_SINGLE_ROW: 25.3 DPM (13%)</a:t>
-            </a:r>
-            <a:br/>
-            <a:r>
-              <a:t>• HGDC: 7.6 DPM (4%)</a:t>
-            </a:r>
-            <a:br/>
-            <a:r>
-              <a:t>• SYS_EVEN_BURST_BIT: 6.9 DPM (4%)</a:t>
-            </a:r>
-            <a:br/>
-            <a:r>
-              <a:t>• ROW: 6.1 DPM (3%)</a:t>
-            </a:r>
-            <a:br/>
-            <a:r>
-              <a:t>• DB: 6.0 DPM (3%)</a:t>
-            </a:r>
-            <a:br/>
-            <a:r>
-              <a:t>• MULTI_HALFBANK_SINGLE_DQ: 5.0 DPM (3%)</a:t>
-            </a:r>
-            <a:br/>
-            <a:r>
-              <a:t>• MULTI_HALFBANK_MULTI_DQ: 4.7 DPM (2%)</a:t>
-            </a:r>
-          </a:p>
-        </p:txBody>
-      </p:sp>
-    </p:spTree>
-  </p:cSld>
-  <p:clrMapOvr>
-    <a:masterClrMapping/>
-  </p:clrMapOvr>
-</p:sld>
-</file>
-
-<file path=ppt/slides/slide6.xml><?xml version="1.0" encoding="utf-8"?>
-<p:sld xmlns:a="http://schemas.openxmlformats.org/drawingml/2006/main" xmlns:p="http://schemas.openxmlformats.org/presentationml/2006/main" xmlns:r="http://schemas.openxmlformats.org/officeDocument/2006/relationships">
-  <p:cSld>
-    <p:spTree>
-      <p:nvGrpSpPr>
-        <p:cNvPr id="1" name=""/>
-        <p:cNvGrpSpPr/>
-        <p:nvPr/>
-      </p:nvGrpSpPr>
-      <p:grpSpPr/>
-      <p:sp>
-        <p:nvSpPr>
-          <p:cNvPr id="2" name="Rectangle 1"/>
-          <p:cNvSpPr/>
-          <p:nvPr/>
-        </p:nvSpPr>
-        <p:spPr>
-          <a:xfrm>
-            <a:off x="0" y="0"/>
-            <a:ext cx="12191695" cy="822960"/>
-          </a:xfrm>
-          <a:prstGeom prst="rect">
+          <a:prstGeom prst="roundRect">
             <a:avLst/>
           </a:prstGeom>
           <a:solidFill>
-            <a:srgbClr val="003366"/>
+            <a:srgbClr val="7B1FA2"/>
           </a:solidFill>
           <a:ln>
             <a:noFill/>
@@ -4550,14 +3672,14 @@
       </p:sp>
       <p:sp>
         <p:nvSpPr>
-          <p:cNvPr id="3" name="TextBox 2"/>
+          <p:cNvPr id="14" name="TextBox 13"/>
           <p:cNvSpPr txBox="1"/>
           <p:nvPr/>
         </p:nvSpPr>
         <p:spPr>
           <a:xfrm>
-            <a:off x="274320" y="182880"/>
-            <a:ext cx="11430000" cy="548640"/>
+            <a:off x="7452360" y="1371600"/>
+            <a:ext cx="2194560" cy="457200"/>
           </a:xfrm>
           <a:prstGeom prst="rect">
             <a:avLst/>
@@ -4570,29 +3692,29 @@
           </a:bodyPr>
           <a:lstStyle/>
           <a:p>
-            <a:pPr>
-              <a:defRPr sz="2800" b="1">
+            <a:pPr algn="ctr">
+              <a:defRPr sz="2400" b="1">
                 <a:solidFill>
                   <a:srgbClr val="FFFFFF"/>
                 </a:solidFill>
               </a:defRPr>
             </a:pPr>
             <a:r>
-              <a:t>Recovery Type Assignments</a:t>
-            </a:r>
-          </a:p>
-        </p:txBody>
-      </p:sp>
-      <p:sp>
-        <p:nvSpPr>
-          <p:cNvPr id="4" name="TextBox 3"/>
+              <a:t>341.4 (71.4%)</a:t>
+            </a:r>
+          </a:p>
+        </p:txBody>
+      </p:sp>
+      <p:sp>
+        <p:nvSpPr>
+          <p:cNvPr id="15" name="TextBox 14"/>
           <p:cNvSpPr txBox="1"/>
           <p:nvPr/>
         </p:nvSpPr>
         <p:spPr>
           <a:xfrm>
-            <a:off x="274320" y="914400"/>
-            <a:ext cx="11612880" cy="5669280"/>
+            <a:off x="7452360" y="1828800"/>
+            <a:ext cx="2194560" cy="365760"/>
           </a:xfrm>
           <a:prstGeom prst="rect">
             <a:avLst/>
@@ -4600,134 +3722,40 @@
           <a:noFill/>
         </p:spPr>
         <p:txBody>
-          <a:bodyPr wrap="square">
+          <a:bodyPr wrap="none">
             <a:spAutoFit/>
           </a:bodyPr>
           <a:lstStyle/>
           <a:p>
-            <a:pPr>
+            <a:pPr algn="ctr">
               <a:defRPr sz="1200">
-                <a:latin typeface="Consolas"/>
+                <a:solidFill>
+                  <a:srgbClr val="FFFFFF"/>
+                </a:solidFill>
               </a:defRPr>
             </a:pPr>
             <a:r>
-              <a:t>Recovery Mechanism Mapping:</a:t>
-            </a:r>
-            <a:br/>
-            <a:br/>
-            <a:r>
-              <a:t>┌─────────────────────────────────────────────────────────────────────────┐</a:t>
-            </a:r>
-            <a:br/>
-            <a:r>
-              <a:t>│ BIOS 100% Recovery (Full recovery projected)                            │</a:t>
-            </a:r>
-            <a:br/>
-            <a:r>
-              <a:t>│   • MULTI_BANK_MULTI_DQ - Multi-bank failures recoverable via BIOS      │</a:t>
-            </a:r>
-            <a:br/>
-            <a:r>
-              <a:t>├─────────────────────────────────────────────────────────────────────────┤</a:t>
-            </a:r>
-            <a:br/>
-            <a:r>
-              <a:t>│ BIOS 50% Recovery (Partial recovery projected)                          │</a:t>
-            </a:r>
-            <a:br/>
-            <a:r>
-              <a:t>│   • SINGLE_BURST_SINGLE_ROW, HGDC, SYS_EVEN_BURST_BIT                   │</a:t>
-            </a:r>
-            <a:br/>
-            <a:r>
-              <a:t>│   • SYS_ODD_BURST_BIT, MULTI_BANK_2ROW, SECTION_FAIL_PERIPH             │</a:t>
-            </a:r>
-            <a:br/>
-            <a:r>
-              <a:t>├─────────────────────────────────────────────────────────────────────────┤</a:t>
-            </a:r>
-            <a:br/>
-            <a:r>
-              <a:t>│ HW+SOP 100% Recovery (Hardware/SOP fixes)                               │</a:t>
-            </a:r>
-            <a:br/>
-            <a:r>
-              <a:t>│   • HANG - System hang recoverable via hardware/SOP improvements        │</a:t>
-            </a:r>
-            <a:br/>
-            <a:r>
-              <a:t>├─────────────────────────────────────────────────────────────────────────┤</a:t>
-            </a:r>
-            <a:br/>
-            <a:r>
-              <a:t>│ RPx 0% Recovery (Verified - No false fails found)                       │</a:t>
-            </a:r>
-            <a:br/>
-            <a:r>
-              <a:t>│   • MULTI_HALFBANK_*, ROW, ROW_LOCAL, MULTI_BANK_SINGLE_DQ              │</a:t>
-            </a:r>
-            <a:br/>
-            <a:r>
-              <a:t>│   • Note: socamm_false_miscompare.py verified 0% false fail rate        │</a:t>
-            </a:r>
-            <a:br/>
-            <a:r>
-              <a:t>├─────────────────────────────────────────────────────────────────────────┤</a:t>
-            </a:r>
-            <a:br/>
-            <a:r>
-              <a:t>│ No Recovery (True failures - customer-facing)                           │</a:t>
-            </a:r>
-            <a:br/>
-            <a:r>
-              <a:t>│   • SB, DB, UNKNOWN, BOOT, SB_MODSYS, SINGLE_BANK, COL_FUSE             │</a:t>
-            </a:r>
-            <a:br/>
-            <a:r>
-              <a:t>└─────────────────────────────────────────────────────────────────────────┘</a:t>
-            </a:r>
-            <a:br/>
-            <a:br/>
-            <a:r>
-              <a:t>Note: ROW MSN_STATUS does NOT get BIOS recovery - only RPx can recover ROW failures</a:t>
-            </a:r>
-          </a:p>
-        </p:txBody>
-      </p:sp>
-    </p:spTree>
-  </p:cSld>
-  <p:clrMapOvr>
-    <a:masterClrMapping/>
-  </p:clrMapOvr>
-</p:sld>
-</file>
-
-<file path=ppt/slides/slide7.xml><?xml version="1.0" encoding="utf-8"?>
-<p:sld xmlns:a="http://schemas.openxmlformats.org/drawingml/2006/main" xmlns:p="http://schemas.openxmlformats.org/presentationml/2006/main" xmlns:r="http://schemas.openxmlformats.org/officeDocument/2006/relationships">
-  <p:cSld>
-    <p:spTree>
-      <p:nvGrpSpPr>
-        <p:cNvPr id="1" name=""/>
-        <p:cNvGrpSpPr/>
-        <p:nvPr/>
-      </p:nvGrpSpPr>
-      <p:grpSpPr/>
-      <p:sp>
-        <p:nvSpPr>
-          <p:cNvPr id="2" name="Rectangle 1"/>
+              <a:t>Total Recoverable</a:t>
+            </a:r>
+          </a:p>
+        </p:txBody>
+      </p:sp>
+      <p:sp>
+        <p:nvSpPr>
+          <p:cNvPr id="16" name="Rounded Rectangle 15"/>
           <p:cNvSpPr/>
           <p:nvPr/>
         </p:nvSpPr>
         <p:spPr>
           <a:xfrm>
-            <a:off x="0" y="0"/>
-            <a:ext cx="12191695" cy="822960"/>
+            <a:off x="9784080" y="1188720"/>
+            <a:ext cx="2194560" cy="1097280"/>
           </a:xfrm>
-          <a:prstGeom prst="rect">
+          <a:prstGeom prst="roundRect">
             <a:avLst/>
           </a:prstGeom>
           <a:solidFill>
-            <a:srgbClr val="003366"/>
+            <a:srgbClr val="F57C00"/>
           </a:solidFill>
           <a:ln>
             <a:noFill/>
@@ -4757,14 +3785,14 @@
       </p:sp>
       <p:sp>
         <p:nvSpPr>
-          <p:cNvPr id="3" name="TextBox 2"/>
+          <p:cNvPr id="17" name="TextBox 16"/>
           <p:cNvSpPr txBox="1"/>
           <p:nvPr/>
         </p:nvSpPr>
         <p:spPr>
           <a:xfrm>
-            <a:off x="274320" y="182880"/>
-            <a:ext cx="11430000" cy="548640"/>
+            <a:off x="9784080" y="1371600"/>
+            <a:ext cx="2194560" cy="457200"/>
           </a:xfrm>
           <a:prstGeom prst="rect">
             <a:avLst/>
@@ -4777,30 +3805,65 @@
           </a:bodyPr>
           <a:lstStyle/>
           <a:p>
-            <a:pPr>
-              <a:defRPr sz="2800" b="1">
+            <a:pPr algn="ctr">
+              <a:defRPr sz="2400" b="1">
                 <a:solidFill>
                   <a:srgbClr val="FFFFFF"/>
                 </a:solidFill>
               </a:defRPr>
             </a:pPr>
             <a:r>
-              <a:t>Recovery Summary by Step</a:t>
+              <a:t>136.6 (28.6%)</a:t>
+            </a:r>
+          </a:p>
+        </p:txBody>
+      </p:sp>
+      <p:sp>
+        <p:nvSpPr>
+          <p:cNvPr id="18" name="TextBox 17"/>
+          <p:cNvSpPr txBox="1"/>
+          <p:nvPr/>
+        </p:nvSpPr>
+        <p:spPr>
+          <a:xfrm>
+            <a:off x="9784080" y="1828800"/>
+            <a:ext cx="2194560" cy="365760"/>
+          </a:xfrm>
+          <a:prstGeom prst="rect">
+            <a:avLst/>
+          </a:prstGeom>
+          <a:noFill/>
+        </p:spPr>
+        <p:txBody>
+          <a:bodyPr wrap="none">
+            <a:spAutoFit/>
+          </a:bodyPr>
+          <a:lstStyle/>
+          <a:p>
+            <a:pPr algn="ctr">
+              <a:defRPr sz="1200">
+                <a:solidFill>
+                  <a:srgbClr val="FFFFFF"/>
+                </a:solidFill>
+              </a:defRPr>
+            </a:pPr>
+            <a:r>
+              <a:t>Customer-Facing</a:t>
             </a:r>
           </a:p>
         </p:txBody>
       </p:sp>
       <p:graphicFrame>
         <p:nvGraphicFramePr>
-          <p:cNvPr id="4" name="Table 3"/>
+          <p:cNvPr id="19" name="Table 18"/>
           <p:cNvGraphicFramePr>
             <a:graphicFrameLocks noGrp="1"/>
           </p:cNvGraphicFramePr>
           <p:nvPr/>
         </p:nvGraphicFramePr>
         <p:xfrm>
-          <a:off x="914400" y="1188720"/>
-          <a:ext cx="10058400" cy="2926080"/>
+          <a:off x="457200" y="2560320"/>
+          <a:ext cx="4572000" cy="2286000"/>
         </p:xfrm>
         <a:graphic>
           <a:graphicData uri="http://schemas.openxmlformats.org/drawingml/2006/table">
@@ -4809,33 +3872,31 @@
                 <a:tableStyleId>{5C22544A-7EE6-4342-B048-85BDC9FD1C3A}</a:tableStyleId>
               </a:tblPr>
               <a:tblGrid>
-                <a:gridCol w="2011680"/>
-                <a:gridCol w="2011680"/>
-                <a:gridCol w="2011680"/>
-                <a:gridCol w="2011680"/>
-                <a:gridCol w="2011680"/>
+                <a:gridCol w="1524000"/>
+                <a:gridCol w="1524000"/>
+                <a:gridCol w="1524000"/>
               </a:tblGrid>
-              <a:tr h="365760">
+              <a:tr h="457200">
                 <a:tc>
                   <a:txBody>
                     <a:bodyPr/>
                     <a:lstStyle/>
                     <a:p>
-                      <a:pPr algn="ctr">
-                        <a:defRPr sz="1400" b="1">
+                      <a:pPr>
+                        <a:defRPr b="1" sz="1400">
                           <a:solidFill>
                             <a:srgbClr val="FFFFFF"/>
                           </a:solidFill>
                         </a:defRPr>
                       </a:pPr>
                       <a:r>
-                        <a:t>Recovery Type</a:t>
+                        <a:t>Category</a:t>
                       </a:r>
                     </a:p>
                   </a:txBody>
                   <a:tcPr>
                     <a:solidFill>
-                      <a:srgbClr val="003366"/>
+                      <a:srgbClr val="1A237E"/>
                     </a:solidFill>
                   </a:tcPr>
                 </a:tc>
@@ -4844,21 +3905,21 @@
                     <a:bodyPr/>
                     <a:lstStyle/>
                     <a:p>
-                      <a:pPr algn="ctr">
-                        <a:defRPr sz="1400" b="1">
+                      <a:pPr>
+                        <a:defRPr b="1" sz="1400">
                           <a:solidFill>
                             <a:srgbClr val="FFFFFF"/>
                           </a:solidFill>
                         </a:defRPr>
                       </a:pPr>
                       <a:r>
-                        <a:t>HMB1 DPM</a:t>
+                        <a:t>DPM</a:t>
                       </a:r>
                     </a:p>
                   </a:txBody>
                   <a:tcPr>
                     <a:solidFill>
-                      <a:srgbClr val="003366"/>
+                      <a:srgbClr val="1A237E"/>
                     </a:solidFill>
                   </a:tcPr>
                 </a:tc>
@@ -4867,82 +3928,36 @@
                     <a:bodyPr/>
                     <a:lstStyle/>
                     <a:p>
-                      <a:pPr algn="ctr">
-                        <a:defRPr sz="1400" b="1">
+                      <a:pPr>
+                        <a:defRPr b="1" sz="1400">
                           <a:solidFill>
                             <a:srgbClr val="FFFFFF"/>
                           </a:solidFill>
                         </a:defRPr>
                       </a:pPr>
                       <a:r>
-                        <a:t>QMON DPM</a:t>
+                        <a:t>Percent</a:t>
                       </a:r>
                     </a:p>
                   </a:txBody>
                   <a:tcPr>
                     <a:solidFill>
-                      <a:srgbClr val="003366"/>
+                      <a:srgbClr val="1A237E"/>
                     </a:solidFill>
                   </a:tcPr>
                 </a:tc>
+              </a:tr>
+              <a:tr h="457200">
                 <a:tc>
                   <a:txBody>
                     <a:bodyPr/>
                     <a:lstStyle/>
                     <a:p>
-                      <a:pPr algn="ctr">
-                        <a:defRPr sz="1400" b="1">
-                          <a:solidFill>
-                            <a:srgbClr val="FFFFFF"/>
-                          </a:solidFill>
-                        </a:defRPr>
+                      <a:pPr>
+                        <a:defRPr sz="1200"/>
                       </a:pPr>
                       <a:r>
-                        <a:t>Combined</a:t>
-                      </a:r>
-                    </a:p>
-                  </a:txBody>
-                  <a:tcPr>
-                    <a:solidFill>
-                      <a:srgbClr val="003366"/>
-                    </a:solidFill>
-                  </a:tcPr>
-                </a:tc>
-                <a:tc>
-                  <a:txBody>
-                    <a:bodyPr/>
-                    <a:lstStyle/>
-                    <a:p>
-                      <a:pPr algn="ctr">
-                        <a:defRPr sz="1400" b="1">
-                          <a:solidFill>
-                            <a:srgbClr val="FFFFFF"/>
-                          </a:solidFill>
-                        </a:defRPr>
-                      </a:pPr>
-                      <a:r>
-                        <a:t>Rate</a:t>
-                      </a:r>
-                    </a:p>
-                  </a:txBody>
-                  <a:tcPr>
-                    <a:solidFill>
-                      <a:srgbClr val="003366"/>
-                    </a:solidFill>
-                  </a:tcPr>
-                </a:tc>
-              </a:tr>
-              <a:tr h="365760">
-                <a:tc>
-                  <a:txBody>
-                    <a:bodyPr/>
-                    <a:lstStyle/>
-                    <a:p>
-                      <a:pPr algn="ctr">
-                        <a:defRPr sz="1400"/>
-                      </a:pPr>
-                      <a:r>
-                        <a:t>BIOS 100%</a:t>
+                        <a:t>BIOS</a:t>
                       </a:r>
                     </a:p>
                   </a:txBody>
@@ -4953,11 +3968,11 @@
                     <a:bodyPr/>
                     <a:lstStyle/>
                     <a:p>
-                      <a:pPr algn="ctr">
-                        <a:defRPr sz="1400"/>
+                      <a:pPr algn="r">
+                        <a:defRPr sz="1200"/>
                       </a:pPr>
                       <a:r>
-                        <a:t>98.0</a:t>
+                        <a:t>322.1</a:t>
                       </a:r>
                     </a:p>
                   </a:txBody>
@@ -4968,132 +3983,25 @@
                     <a:bodyPr/>
                     <a:lstStyle/>
                     <a:p>
-                      <a:pPr algn="ctr">
-                        <a:defRPr sz="1400"/>
+                      <a:pPr algn="r">
+                        <a:defRPr sz="1200"/>
                       </a:pPr>
                       <a:r>
-                        <a:t>105.5</a:t>
-                      </a:r>
-                    </a:p>
-                  </a:txBody>
-                  <a:tcPr/>
-                </a:tc>
-                <a:tc>
-                  <a:txBody>
-                    <a:bodyPr/>
-                    <a:lstStyle/>
-                    <a:p>
-                      <a:pPr algn="ctr">
-                        <a:defRPr sz="1400"/>
-                      </a:pPr>
-                      <a:r>
-                        <a:t>203.5</a:t>
-                      </a:r>
-                    </a:p>
-                  </a:txBody>
-                  <a:tcPr/>
-                </a:tc>
-                <a:tc>
-                  <a:txBody>
-                    <a:bodyPr/>
-                    <a:lstStyle/>
-                    <a:p>
-                      <a:pPr algn="ctr">
-                        <a:defRPr sz="1400"/>
-                      </a:pPr>
-                      <a:r>
-                        <a:t>100%</a:t>
+                        <a:t>67.4%</a:t>
                       </a:r>
                     </a:p>
                   </a:txBody>
                   <a:tcPr/>
                 </a:tc>
               </a:tr>
-              <a:tr h="365760">
+              <a:tr h="457200">
                 <a:tc>
                   <a:txBody>
                     <a:bodyPr/>
                     <a:lstStyle/>
                     <a:p>
-                      <a:pPr algn="ctr">
-                        <a:defRPr sz="1400"/>
-                      </a:pPr>
-                      <a:r>
-                        <a:t>BIOS 50%</a:t>
-                      </a:r>
-                    </a:p>
-                  </a:txBody>
-                  <a:tcPr/>
-                </a:tc>
-                <a:tc>
-                  <a:txBody>
-                    <a:bodyPr/>
-                    <a:lstStyle/>
-                    <a:p>
-                      <a:pPr algn="ctr">
-                        <a:defRPr sz="1400"/>
-                      </a:pPr>
-                      <a:r>
-                        <a:t>53.2</a:t>
-                      </a:r>
-                    </a:p>
-                  </a:txBody>
-                  <a:tcPr/>
-                </a:tc>
-                <a:tc>
-                  <a:txBody>
-                    <a:bodyPr/>
-                    <a:lstStyle/>
-                    <a:p>
-                      <a:pPr algn="ctr">
-                        <a:defRPr sz="1400"/>
-                      </a:pPr>
-                      <a:r>
-                        <a:t>25.6</a:t>
-                      </a:r>
-                    </a:p>
-                  </a:txBody>
-                  <a:tcPr/>
-                </a:tc>
-                <a:tc>
-                  <a:txBody>
-                    <a:bodyPr/>
-                    <a:lstStyle/>
-                    <a:p>
-                      <a:pPr algn="ctr">
-                        <a:defRPr sz="1400"/>
-                      </a:pPr>
-                      <a:r>
-                        <a:t>78.8</a:t>
-                      </a:r>
-                    </a:p>
-                  </a:txBody>
-                  <a:tcPr/>
-                </a:tc>
-                <a:tc>
-                  <a:txBody>
-                    <a:bodyPr/>
-                    <a:lstStyle/>
-                    <a:p>
-                      <a:pPr algn="ctr">
-                        <a:defRPr sz="1400"/>
-                      </a:pPr>
-                      <a:r>
-                        <a:t>50%</a:t>
-                      </a:r>
-                    </a:p>
-                  </a:txBody>
-                  <a:tcPr/>
-                </a:tc>
-              </a:tr>
-              <a:tr h="365760">
-                <a:tc>
-                  <a:txBody>
-                    <a:bodyPr/>
-                    <a:lstStyle/>
-                    <a:p>
-                      <a:pPr algn="ctr">
-                        <a:defRPr sz="1400"/>
+                      <a:pPr>
+                        <a:defRPr sz="1200"/>
                       </a:pPr>
                       <a:r>
                         <a:t>HW+SOP</a:t>
@@ -5107,11 +4015,11 @@
                     <a:bodyPr/>
                     <a:lstStyle/>
                     <a:p>
-                      <a:pPr algn="ctr">
-                        <a:defRPr sz="1400"/>
+                      <a:pPr algn="r">
+                        <a:defRPr sz="1200"/>
                       </a:pPr>
                       <a:r>
-                        <a:t>15.9</a:t>
+                        <a:t>19.3</a:t>
                       </a:r>
                     </a:p>
                   </a:txBody>
@@ -5122,141 +4030,34 @@
                     <a:bodyPr/>
                     <a:lstStyle/>
                     <a:p>
-                      <a:pPr algn="ctr">
-                        <a:defRPr sz="1400"/>
+                      <a:pPr algn="r">
+                        <a:defRPr sz="1200"/>
                       </a:pPr>
                       <a:r>
-                        <a:t>0.7</a:t>
-                      </a:r>
-                    </a:p>
-                  </a:txBody>
-                  <a:tcPr/>
-                </a:tc>
-                <a:tc>
-                  <a:txBody>
-                    <a:bodyPr/>
-                    <a:lstStyle/>
-                    <a:p>
-                      <a:pPr algn="ctr">
-                        <a:defRPr sz="1400"/>
-                      </a:pPr>
-                      <a:r>
-                        <a:t>16.6</a:t>
-                      </a:r>
-                    </a:p>
-                  </a:txBody>
-                  <a:tcPr/>
-                </a:tc>
-                <a:tc>
-                  <a:txBody>
-                    <a:bodyPr/>
-                    <a:lstStyle/>
-                    <a:p>
-                      <a:pPr algn="ctr">
-                        <a:defRPr sz="1400"/>
-                      </a:pPr>
-                      <a:r>
-                        <a:t>100%</a:t>
+                        <a:t>4.0%</a:t>
                       </a:r>
                     </a:p>
                   </a:txBody>
                   <a:tcPr/>
                 </a:tc>
               </a:tr>
-              <a:tr h="365760">
+              <a:tr h="457200">
                 <a:tc>
                   <a:txBody>
                     <a:bodyPr/>
                     <a:lstStyle/>
                     <a:p>
-                      <a:pPr algn="ctr">
-                        <a:defRPr sz="1400"/>
+                      <a:pPr>
+                        <a:defRPr sz="1200"/>
                       </a:pPr>
                       <a:r>
-                        <a:t>RPx (Verified)</a:t>
-                      </a:r>
-                    </a:p>
-                  </a:txBody>
-                  <a:tcPr/>
-                </a:tc>
-                <a:tc>
-                  <a:txBody>
-                    <a:bodyPr/>
-                    <a:lstStyle/>
-                    <a:p>
-                      <a:pPr algn="ctr">
-                        <a:defRPr sz="1400"/>
-                      </a:pPr>
-                      <a:r>
-                        <a:t>0.0</a:t>
-                      </a:r>
-                    </a:p>
-                  </a:txBody>
-                  <a:tcPr/>
-                </a:tc>
-                <a:tc>
-                  <a:txBody>
-                    <a:bodyPr/>
-                    <a:lstStyle/>
-                    <a:p>
-                      <a:pPr algn="ctr">
-                        <a:defRPr sz="1400"/>
-                      </a:pPr>
-                      <a:r>
-                        <a:t>0.0</a:t>
-                      </a:r>
-                    </a:p>
-                  </a:txBody>
-                  <a:tcPr/>
-                </a:tc>
-                <a:tc>
-                  <a:txBody>
-                    <a:bodyPr/>
-                    <a:lstStyle/>
-                    <a:p>
-                      <a:pPr algn="ctr">
-                        <a:defRPr sz="1400"/>
-                      </a:pPr>
-                      <a:r>
-                        <a:t>0.0</a:t>
-                      </a:r>
-                    </a:p>
-                  </a:txBody>
-                  <a:tcPr/>
-                </a:tc>
-                <a:tc>
-                  <a:txBody>
-                    <a:bodyPr/>
-                    <a:lstStyle/>
-                    <a:p>
-                      <a:pPr algn="ctr">
-                        <a:defRPr sz="1400"/>
-                      </a:pPr>
-                      <a:r>
-                        <a:t>0%</a:t>
-                      </a:r>
-                    </a:p>
-                  </a:txBody>
-                  <a:tcPr/>
-                </a:tc>
-              </a:tr>
-              <a:tr h="365760">
-                <a:tc>
-                  <a:txBody>
-                    <a:bodyPr/>
-                    <a:lstStyle/>
-                    <a:p>
-                      <a:pPr algn="ctr">
-                        <a:defRPr sz="1400" b="1"/>
-                      </a:pPr>
-                      <a:r>
-                        <a:t>Total Recovered</a:t>
+                        <a:t>Recoverable</a:t>
                       </a:r>
                     </a:p>
                   </a:txBody>
                   <a:tcPr>
                     <a:solidFill>
-                      <a:srgbClr val="C6E0B4"/>
+                      <a:srgbClr val="E8F5E9"/>
                     </a:solidFill>
                   </a:tcPr>
                 </a:tc>
@@ -5265,17 +4066,17 @@
                     <a:bodyPr/>
                     <a:lstStyle/>
                     <a:p>
-                      <a:pPr algn="ctr">
-                        <a:defRPr sz="1400" b="1"/>
+                      <a:pPr algn="r">
+                        <a:defRPr sz="1200"/>
                       </a:pPr>
                       <a:r>
-                        <a:t>167.2</a:t>
+                        <a:t>341.4</a:t>
                       </a:r>
                     </a:p>
                   </a:txBody>
                   <a:tcPr>
                     <a:solidFill>
-                      <a:srgbClr val="C6E0B4"/>
+                      <a:srgbClr val="E8F5E9"/>
                     </a:solidFill>
                   </a:tcPr>
                 </a:tc>
@@ -5284,17 +4085,38 @@
                     <a:bodyPr/>
                     <a:lstStyle/>
                     <a:p>
-                      <a:pPr algn="ctr">
-                        <a:defRPr sz="1400" b="1"/>
+                      <a:pPr algn="r">
+                        <a:defRPr sz="1200"/>
                       </a:pPr>
                       <a:r>
-                        <a:t>131.8</a:t>
+                        <a:t>71.4%</a:t>
                       </a:r>
                     </a:p>
                   </a:txBody>
                   <a:tcPr>
                     <a:solidFill>
-                      <a:srgbClr val="C6E0B4"/>
+                      <a:srgbClr val="E8F5E9"/>
+                    </a:solidFill>
+                  </a:tcPr>
+                </a:tc>
+              </a:tr>
+              <a:tr h="457200">
+                <a:tc>
+                  <a:txBody>
+                    <a:bodyPr/>
+                    <a:lstStyle/>
+                    <a:p>
+                      <a:pPr>
+                        <a:defRPr sz="1200"/>
+                      </a:pPr>
+                      <a:r>
+                        <a:t>Remaining</a:t>
+                      </a:r>
+                    </a:p>
+                  </a:txBody>
+                  <a:tcPr>
+                    <a:solidFill>
+                      <a:srgbClr val="FFF3E0"/>
                     </a:solidFill>
                   </a:tcPr>
                 </a:tc>
@@ -5303,17 +4125,17 @@
                     <a:bodyPr/>
                     <a:lstStyle/>
                     <a:p>
-                      <a:pPr algn="ctr">
-                        <a:defRPr sz="1400" b="1"/>
+                      <a:pPr algn="r">
+                        <a:defRPr sz="1200"/>
                       </a:pPr>
                       <a:r>
-                        <a:t>298.9</a:t>
+                        <a:t>136.6</a:t>
                       </a:r>
                     </a:p>
                   </a:txBody>
                   <a:tcPr>
                     <a:solidFill>
-                      <a:srgbClr val="C6E0B4"/>
+                      <a:srgbClr val="FFF3E0"/>
                     </a:solidFill>
                   </a:tcPr>
                 </a:tc>
@@ -5322,191 +4144,17 @@
                     <a:bodyPr/>
                     <a:lstStyle/>
                     <a:p>
-                      <a:pPr algn="ctr">
-                        <a:defRPr sz="1400" b="1"/>
+                      <a:pPr algn="r">
+                        <a:defRPr sz="1200"/>
                       </a:pPr>
                       <a:r>
-                        <a:t>-</a:t>
+                        <a:t>28.6%</a:t>
                       </a:r>
                     </a:p>
                   </a:txBody>
                   <a:tcPr>
                     <a:solidFill>
-                      <a:srgbClr val="C6E0B4"/>
-                    </a:solidFill>
-                  </a:tcPr>
-                </a:tc>
-              </a:tr>
-              <a:tr h="365760">
-                <a:tc>
-                  <a:txBody>
-                    <a:bodyPr/>
-                    <a:lstStyle/>
-                    <a:p>
-                      <a:pPr algn="ctr">
-                        <a:defRPr sz="1400"/>
-                      </a:pPr>
-                      <a:r>
-                        <a:t>No Recovery</a:t>
-                      </a:r>
-                    </a:p>
-                  </a:txBody>
-                  <a:tcPr/>
-                </a:tc>
-                <a:tc>
-                  <a:txBody>
-                    <a:bodyPr/>
-                    <a:lstStyle/>
-                    <a:p>
-                      <a:pPr algn="ctr">
-                        <a:defRPr sz="1400"/>
-                      </a:pPr>
-                      <a:r>
-                        <a:t>41.3</a:t>
-                      </a:r>
-                    </a:p>
-                  </a:txBody>
-                  <a:tcPr/>
-                </a:tc>
-                <a:tc>
-                  <a:txBody>
-                    <a:bodyPr/>
-                    <a:lstStyle/>
-                    <a:p>
-                      <a:pPr algn="ctr">
-                        <a:defRPr sz="1400"/>
-                      </a:pPr>
-                      <a:r>
-                        <a:t>30.9</a:t>
-                      </a:r>
-                    </a:p>
-                  </a:txBody>
-                  <a:tcPr/>
-                </a:tc>
-                <a:tc>
-                  <a:txBody>
-                    <a:bodyPr/>
-                    <a:lstStyle/>
-                    <a:p>
-                      <a:pPr algn="ctr">
-                        <a:defRPr sz="1400"/>
-                      </a:pPr>
-                      <a:r>
-                        <a:t>72.2</a:t>
-                      </a:r>
-                    </a:p>
-                  </a:txBody>
-                  <a:tcPr/>
-                </a:tc>
-                <a:tc>
-                  <a:txBody>
-                    <a:bodyPr/>
-                    <a:lstStyle/>
-                    <a:p>
-                      <a:pPr algn="ctr">
-                        <a:defRPr sz="1400"/>
-                      </a:pPr>
-                      <a:r>
-                        <a:t>0%</a:t>
-                      </a:r>
-                    </a:p>
-                  </a:txBody>
-                  <a:tcPr/>
-                </a:tc>
-              </a:tr>
-              <a:tr h="365760">
-                <a:tc>
-                  <a:txBody>
-                    <a:bodyPr/>
-                    <a:lstStyle/>
-                    <a:p>
-                      <a:pPr algn="ctr">
-                        <a:defRPr sz="1400" b="1"/>
-                      </a:pPr>
-                      <a:r>
-                        <a:t>Customer-Facing</a:t>
-                      </a:r>
-                    </a:p>
-                  </a:txBody>
-                  <a:tcPr>
-                    <a:solidFill>
-                      <a:srgbClr val="FFEB9C"/>
-                    </a:solidFill>
-                  </a:tcPr>
-                </a:tc>
-                <a:tc>
-                  <a:txBody>
-                    <a:bodyPr/>
-                    <a:lstStyle/>
-                    <a:p>
-                      <a:pPr algn="ctr">
-                        <a:defRPr sz="1400" b="1"/>
-                      </a:pPr>
-                      <a:r>
-                        <a:t>98.6</a:t>
-                      </a:r>
-                    </a:p>
-                  </a:txBody>
-                  <a:tcPr>
-                    <a:solidFill>
-                      <a:srgbClr val="FFEB9C"/>
-                    </a:solidFill>
-                  </a:tcPr>
-                </a:tc>
-                <a:tc>
-                  <a:txBody>
-                    <a:bodyPr/>
-                    <a:lstStyle/>
-                    <a:p>
-                      <a:pPr algn="ctr">
-                        <a:defRPr sz="1400" b="1"/>
-                      </a:pPr>
-                      <a:r>
-                        <a:t>59.4</a:t>
-                      </a:r>
-                    </a:p>
-                  </a:txBody>
-                  <a:tcPr>
-                    <a:solidFill>
-                      <a:srgbClr val="FFEB9C"/>
-                    </a:solidFill>
-                  </a:tcPr>
-                </a:tc>
-                <a:tc>
-                  <a:txBody>
-                    <a:bodyPr/>
-                    <a:lstStyle/>
-                    <a:p>
-                      <a:pPr algn="ctr">
-                        <a:defRPr sz="1400" b="1"/>
-                      </a:pPr>
-                      <a:r>
-                        <a:t>157.9</a:t>
-                      </a:r>
-                    </a:p>
-                  </a:txBody>
-                  <a:tcPr>
-                    <a:solidFill>
-                      <a:srgbClr val="FFEB9C"/>
-                    </a:solidFill>
-                  </a:tcPr>
-                </a:tc>
-                <a:tc>
-                  <a:txBody>
-                    <a:bodyPr/>
-                    <a:lstStyle/>
-                    <a:p>
-                      <a:pPr algn="ctr">
-                        <a:defRPr sz="1400" b="1"/>
-                      </a:pPr>
-                      <a:r>
-                        <a:t>-</a:t>
-                      </a:r>
-                    </a:p>
-                  </a:txBody>
-                  <a:tcPr>
-                    <a:solidFill>
-                      <a:srgbClr val="FFEB9C"/>
+                      <a:srgbClr val="FFF3E0"/>
                     </a:solidFill>
                   </a:tcPr>
                 </a:tc>
@@ -5515,6 +4163,192 @@
           </a:graphicData>
         </a:graphic>
       </p:graphicFrame>
+      <p:sp>
+        <p:nvSpPr>
+          <p:cNvPr id="20" name="Rounded Rectangle 19"/>
+          <p:cNvSpPr/>
+          <p:nvPr/>
+        </p:nvSpPr>
+        <p:spPr>
+          <a:xfrm>
+            <a:off x="5486400" y="2560320"/>
+            <a:ext cx="6217920" cy="3657600"/>
+          </a:xfrm>
+          <a:prstGeom prst="roundRect">
+            <a:avLst/>
+          </a:prstGeom>
+          <a:solidFill>
+            <a:srgbClr val="F5F5F5"/>
+          </a:solidFill>
+          <a:ln>
+            <a:solidFill>
+              <a:srgbClr val="C8C8C8"/>
+            </a:solidFill>
+          </a:ln>
+        </p:spPr>
+        <p:style>
+          <a:lnRef idx="1">
+            <a:schemeClr val="accent1"/>
+          </a:lnRef>
+          <a:fillRef idx="3">
+            <a:schemeClr val="accent1"/>
+          </a:fillRef>
+          <a:effectRef idx="2">
+            <a:schemeClr val="accent1"/>
+          </a:effectRef>
+          <a:fontRef idx="minor">
+            <a:schemeClr val="lt1"/>
+          </a:fontRef>
+        </p:style>
+        <p:txBody>
+          <a:bodyPr rtlCol="0" anchor="ctr"/>
+          <a:lstStyle/>
+          <a:p>
+            <a:pPr algn="ctr"/>
+          </a:p>
+        </p:txBody>
+      </p:sp>
+      <p:sp>
+        <p:nvSpPr>
+          <p:cNvPr id="21" name="TextBox 20"/>
+          <p:cNvSpPr txBox="1"/>
+          <p:nvPr/>
+        </p:nvSpPr>
+        <p:spPr>
+          <a:xfrm>
+            <a:off x="5669280" y="2743200"/>
+            <a:ext cx="5852160" cy="365760"/>
+          </a:xfrm>
+          <a:prstGeom prst="rect">
+            <a:avLst/>
+          </a:prstGeom>
+          <a:noFill/>
+        </p:spPr>
+        <p:txBody>
+          <a:bodyPr wrap="none">
+            <a:spAutoFit/>
+          </a:bodyPr>
+          <a:lstStyle/>
+          <a:p>
+            <a:pPr algn="ctr">
+              <a:defRPr sz="1400" b="1"/>
+            </a:pPr>
+            <a:r>
+              <a:t>cDPM Recovery Waterfall</a:t>
+            </a:r>
+          </a:p>
+        </p:txBody>
+      </p:sp>
+      <p:sp>
+        <p:nvSpPr>
+          <p:cNvPr id="22" name="TextBox 21"/>
+          <p:cNvSpPr txBox="1"/>
+          <p:nvPr/>
+        </p:nvSpPr>
+        <p:spPr>
+          <a:xfrm>
+            <a:off x="5760720" y="3200400"/>
+            <a:ext cx="5852160" cy="2743200"/>
+          </a:xfrm>
+          <a:prstGeom prst="rect">
+            <a:avLst/>
+          </a:prstGeom>
+          <a:noFill/>
+        </p:spPr>
+        <p:txBody>
+          <a:bodyPr wrap="square">
+            <a:spAutoFit/>
+          </a:bodyPr>
+          <a:lstStyle/>
+          <a:p>
+            <a:br/>
+            <a:pPr>
+              <a:defRPr sz="1000">
+                <a:latin typeface="Courier New"/>
+              </a:defRPr>
+            </a:pPr>
+            <a:r>
+              <a:t>  478.0 ━━━━━━━━━━━━━━━━━━━━━━━━━━━━━━━┓ Total</a:t>
+            </a:r>
+            <a:br/>
+            <a:r>
+              <a:t>         ┃                              ┃</a:t>
+            </a:r>
+            <a:br/>
+            <a:r>
+              <a:t>         ┃  ▓▓▓▓▓▓▓▓▓▓▓▓▓▓▓▓ BIOS       ┃</a:t>
+            </a:r>
+            <a:br/>
+            <a:r>
+              <a:t>         ┃  322.1 (67.4%)               ┃</a:t>
+            </a:r>
+            <a:br/>
+            <a:r>
+              <a:t>         ┃                              ┃</a:t>
+            </a:r>
+            <a:br/>
+            <a:r>
+              <a:t>         ┃     ▓▓ HW+SOP                ┃</a:t>
+            </a:r>
+            <a:br/>
+            <a:r>
+              <a:t>         ┃     19.3 (4.0%)              ┃</a:t>
+            </a:r>
+            <a:br/>
+            <a:r>
+              <a:t>         ┃                              ┃</a:t>
+            </a:r>
+            <a:br/>
+            <a:r>
+              <a:t>  136.6 ━┛━━━━━━━━━━━━━━━━━━━━━━━━━━━━━━┛ Customer-Facing</a:t>
+            </a:r>
+            <a:br/>
+            <a:r>
+              <a:t>         </a:t>
+            </a:r>
+            <a:br/>
+            <a:r>
+              <a:t>  ▓ BIOS (Combined 100%+50%)  ▓ HW+SOP  □ Remaining</a:t>
+            </a:r>
+            <a:br/>
+          </a:p>
+        </p:txBody>
+      </p:sp>
+      <p:sp>
+        <p:nvSpPr>
+          <p:cNvPr id="23" name="TextBox 22"/>
+          <p:cNvSpPr txBox="1"/>
+          <p:nvPr/>
+        </p:nvSpPr>
+        <p:spPr>
+          <a:xfrm>
+            <a:off x="457200" y="5029200"/>
+            <a:ext cx="10972800" cy="457200"/>
+          </a:xfrm>
+          <a:prstGeom prst="rect">
+            <a:avLst/>
+          </a:prstGeom>
+          <a:noFill/>
+        </p:spPr>
+        <p:txBody>
+          <a:bodyPr wrap="none">
+            <a:spAutoFit/>
+          </a:bodyPr>
+          <a:lstStyle/>
+          <a:p>
+            <a:pPr>
+              <a:defRPr sz="1000" i="1">
+                <a:solidFill>
+                  <a:srgbClr val="646464"/>
+                </a:solidFill>
+              </a:defRPr>
+            </a:pPr>
+            <a:r>
+              <a:t>Note: BIOS = MULTI_BANK_MULTI_DQ (100%) + Bank/Burst/Periph patterns (50% partial)</a:t>
+            </a:r>
+          </a:p>
+        </p:txBody>
+      </p:sp>
     </p:spTree>
   </p:cSld>
   <p:clrMapOvr>
@@ -5523,7 +4357,7 @@
 </p:sld>
 </file>
 
-<file path=ppt/slides/slide8.xml><?xml version="1.0" encoding="utf-8"?>
+<file path=ppt/slides/slide3.xml><?xml version="1.0" encoding="utf-8"?>
 <p:sld xmlns:a="http://schemas.openxmlformats.org/drawingml/2006/main" xmlns:p="http://schemas.openxmlformats.org/presentationml/2006/main" xmlns:r="http://schemas.openxmlformats.org/officeDocument/2006/relationships">
   <p:cSld>
     <p:spTree>
@@ -5541,14 +4375,14 @@
         </p:nvSpPr>
         <p:spPr>
           <a:xfrm>
-            <a:off x="868679" y="1787236"/>
-            <a:ext cx="1005840" cy="4156363"/>
+            <a:off x="0" y="0"/>
+            <a:ext cx="12191695" cy="914400"/>
           </a:xfrm>
           <a:prstGeom prst="rect">
             <a:avLst/>
           </a:prstGeom>
           <a:solidFill>
-            <a:srgbClr val="0070C0"/>
+            <a:srgbClr val="1A237E"/>
           </a:solidFill>
           <a:ln>
             <a:noFill/>
@@ -5584,1066 +4418,8 @@
         </p:nvSpPr>
         <p:spPr>
           <a:xfrm>
-            <a:off x="868679" y="1467196"/>
-            <a:ext cx="1005840" cy="274320"/>
-          </a:xfrm>
-          <a:prstGeom prst="rect">
-            <a:avLst/>
-          </a:prstGeom>
-          <a:noFill/>
-        </p:spPr>
-        <p:txBody>
-          <a:bodyPr wrap="none">
-            <a:spAutoFit/>
-          </a:bodyPr>
-          <a:lstStyle/>
-          <a:p>
-            <a:pPr algn="ctr">
-              <a:defRPr sz="1100" b="1">
-                <a:solidFill>
-                  <a:srgbClr val="000000"/>
-                </a:solidFill>
-              </a:defRPr>
-            </a:pPr>
-            <a:r>
-              <a:t>478.0</a:t>
-            </a:r>
-          </a:p>
-        </p:txBody>
-      </p:sp>
-      <p:sp>
-        <p:nvSpPr>
-          <p:cNvPr id="4" name="TextBox 3"/>
-          <p:cNvSpPr txBox="1"/>
-          <p:nvPr/>
-        </p:nvSpPr>
-        <p:spPr>
-          <a:xfrm>
-            <a:off x="868679" y="6035040"/>
-            <a:ext cx="1005840" cy="457200"/>
-          </a:xfrm>
-          <a:prstGeom prst="rect">
-            <a:avLst/>
-          </a:prstGeom>
-          <a:noFill/>
-        </p:spPr>
-        <p:txBody>
-          <a:bodyPr wrap="none">
-            <a:spAutoFit/>
-          </a:bodyPr>
-          <a:lstStyle/>
-          <a:p>
-            <a:pPr algn="ctr">
-              <a:defRPr sz="1000" b="1"/>
-            </a:pPr>
-            <a:r>
-              <a:t>Total cDPM</a:t>
-            </a:r>
-          </a:p>
-        </p:txBody>
-      </p:sp>
-      <p:sp>
-        <p:nvSpPr>
-          <p:cNvPr id="5" name="Rectangle 4"/>
-          <p:cNvSpPr/>
-          <p:nvPr/>
-        </p:nvSpPr>
-        <p:spPr>
-          <a:xfrm>
-            <a:off x="2148839" y="1787236"/>
-            <a:ext cx="1005840" cy="1996210"/>
-          </a:xfrm>
-          <a:prstGeom prst="rect">
-            <a:avLst/>
-          </a:prstGeom>
-          <a:solidFill>
-            <a:srgbClr val="FF6347"/>
-          </a:solidFill>
-          <a:ln>
-            <a:noFill/>
-          </a:ln>
-        </p:spPr>
-        <p:style>
-          <a:lnRef idx="1">
-            <a:schemeClr val="accent1"/>
-          </a:lnRef>
-          <a:fillRef idx="3">
-            <a:schemeClr val="accent1"/>
-          </a:fillRef>
-          <a:effectRef idx="2">
-            <a:schemeClr val="accent1"/>
-          </a:effectRef>
-          <a:fontRef idx="minor">
-            <a:schemeClr val="lt1"/>
-          </a:fontRef>
-        </p:style>
-        <p:txBody>
-          <a:bodyPr rtlCol="0" anchor="ctr"/>
-          <a:lstStyle/>
-          <a:p>
-            <a:pPr algn="ctr"/>
-          </a:p>
-        </p:txBody>
-      </p:sp>
-      <p:sp>
-        <p:nvSpPr>
-          <p:cNvPr id="6" name="TextBox 5"/>
-          <p:cNvSpPr txBox="1"/>
-          <p:nvPr/>
-        </p:nvSpPr>
-        <p:spPr>
-          <a:xfrm>
-            <a:off x="2148839" y="2648181"/>
-            <a:ext cx="1005840" cy="274320"/>
-          </a:xfrm>
-          <a:prstGeom prst="rect">
-            <a:avLst/>
-          </a:prstGeom>
-          <a:noFill/>
-        </p:spPr>
-        <p:txBody>
-          <a:bodyPr wrap="none">
-            <a:spAutoFit/>
-          </a:bodyPr>
-          <a:lstStyle/>
-          <a:p>
-            <a:pPr algn="ctr">
-              <a:defRPr sz="1100" b="1">
-                <a:solidFill>
-                  <a:srgbClr val="000000"/>
-                </a:solidFill>
-              </a:defRPr>
-            </a:pPr>
-            <a:r>
-              <a:t>-229.6</a:t>
-            </a:r>
-          </a:p>
-        </p:txBody>
-      </p:sp>
-      <p:sp>
-        <p:nvSpPr>
-          <p:cNvPr id="7" name="TextBox 6"/>
-          <p:cNvSpPr txBox="1"/>
-          <p:nvPr/>
-        </p:nvSpPr>
-        <p:spPr>
-          <a:xfrm>
-            <a:off x="2148839" y="6035040"/>
-            <a:ext cx="1005840" cy="457200"/>
-          </a:xfrm>
-          <a:prstGeom prst="rect">
-            <a:avLst/>
-          </a:prstGeom>
-          <a:noFill/>
-        </p:spPr>
-        <p:txBody>
-          <a:bodyPr wrap="none">
-            <a:spAutoFit/>
-          </a:bodyPr>
-          <a:lstStyle/>
-          <a:p>
-            <a:pPr algn="ctr">
-              <a:defRPr sz="1000" b="1"/>
-            </a:pPr>
-            <a:r>
-              <a:t>BIOS 100%</a:t>
-            </a:r>
-          </a:p>
-        </p:txBody>
-      </p:sp>
-      <p:sp>
-        <p:nvSpPr>
-          <p:cNvPr id="8" name="Rectangle 7"/>
-          <p:cNvSpPr/>
-          <p:nvPr/>
-        </p:nvSpPr>
-        <p:spPr>
-          <a:xfrm>
-            <a:off x="3428999" y="3783447"/>
-            <a:ext cx="1005840" cy="812744"/>
-          </a:xfrm>
-          <a:prstGeom prst="rect">
-            <a:avLst/>
-          </a:prstGeom>
-          <a:solidFill>
-            <a:srgbClr val="FF6347"/>
-          </a:solidFill>
-          <a:ln>
-            <a:noFill/>
-          </a:ln>
-        </p:spPr>
-        <p:style>
-          <a:lnRef idx="1">
-            <a:schemeClr val="accent1"/>
-          </a:lnRef>
-          <a:fillRef idx="3">
-            <a:schemeClr val="accent1"/>
-          </a:fillRef>
-          <a:effectRef idx="2">
-            <a:schemeClr val="accent1"/>
-          </a:effectRef>
-          <a:fontRef idx="minor">
-            <a:schemeClr val="lt1"/>
-          </a:fontRef>
-        </p:style>
-        <p:txBody>
-          <a:bodyPr rtlCol="0" anchor="ctr"/>
-          <a:lstStyle/>
-          <a:p>
-            <a:pPr algn="ctr"/>
-          </a:p>
-        </p:txBody>
-      </p:sp>
-      <p:sp>
-        <p:nvSpPr>
-          <p:cNvPr id="9" name="TextBox 8"/>
-          <p:cNvSpPr txBox="1"/>
-          <p:nvPr/>
-        </p:nvSpPr>
-        <p:spPr>
-          <a:xfrm>
-            <a:off x="3428999" y="4052659"/>
-            <a:ext cx="1005840" cy="274320"/>
-          </a:xfrm>
-          <a:prstGeom prst="rect">
-            <a:avLst/>
-          </a:prstGeom>
-          <a:noFill/>
-        </p:spPr>
-        <p:txBody>
-          <a:bodyPr wrap="none">
-            <a:spAutoFit/>
-          </a:bodyPr>
-          <a:lstStyle/>
-          <a:p>
-            <a:pPr algn="ctr">
-              <a:defRPr sz="1100" b="1">
-                <a:solidFill>
-                  <a:srgbClr val="000000"/>
-                </a:solidFill>
-              </a:defRPr>
-            </a:pPr>
-            <a:r>
-              <a:t>-93.5</a:t>
-            </a:r>
-          </a:p>
-        </p:txBody>
-      </p:sp>
-      <p:sp>
-        <p:nvSpPr>
-          <p:cNvPr id="10" name="TextBox 9"/>
-          <p:cNvSpPr txBox="1"/>
-          <p:nvPr/>
-        </p:nvSpPr>
-        <p:spPr>
-          <a:xfrm>
-            <a:off x="3428999" y="6035040"/>
-            <a:ext cx="1005840" cy="457200"/>
-          </a:xfrm>
-          <a:prstGeom prst="rect">
-            <a:avLst/>
-          </a:prstGeom>
-          <a:noFill/>
-        </p:spPr>
-        <p:txBody>
-          <a:bodyPr wrap="none">
-            <a:spAutoFit/>
-          </a:bodyPr>
-          <a:lstStyle/>
-          <a:p>
-            <a:pPr algn="ctr">
-              <a:defRPr sz="1000" b="1"/>
-            </a:pPr>
-            <a:r>
-              <a:t>BIOS 50%</a:t>
-            </a:r>
-          </a:p>
-        </p:txBody>
-      </p:sp>
-      <p:sp>
-        <p:nvSpPr>
-          <p:cNvPr id="11" name="Rectangle 10"/>
-          <p:cNvSpPr/>
-          <p:nvPr/>
-        </p:nvSpPr>
-        <p:spPr>
-          <a:xfrm>
-            <a:off x="4709159" y="4596191"/>
-            <a:ext cx="1005840" cy="156952"/>
-          </a:xfrm>
-          <a:prstGeom prst="rect">
-            <a:avLst/>
-          </a:prstGeom>
-          <a:solidFill>
-            <a:srgbClr val="FF6347"/>
-          </a:solidFill>
-          <a:ln>
-            <a:noFill/>
-          </a:ln>
-        </p:spPr>
-        <p:style>
-          <a:lnRef idx="1">
-            <a:schemeClr val="accent1"/>
-          </a:lnRef>
-          <a:fillRef idx="3">
-            <a:schemeClr val="accent1"/>
-          </a:fillRef>
-          <a:effectRef idx="2">
-            <a:schemeClr val="accent1"/>
-          </a:effectRef>
-          <a:fontRef idx="minor">
-            <a:schemeClr val="lt1"/>
-          </a:fontRef>
-        </p:style>
-        <p:txBody>
-          <a:bodyPr rtlCol="0" anchor="ctr"/>
-          <a:lstStyle/>
-          <a:p>
-            <a:pPr algn="ctr"/>
-          </a:p>
-        </p:txBody>
-      </p:sp>
-      <p:sp>
-        <p:nvSpPr>
-          <p:cNvPr id="12" name="TextBox 11"/>
-          <p:cNvSpPr txBox="1"/>
-          <p:nvPr/>
-        </p:nvSpPr>
-        <p:spPr>
-          <a:xfrm>
-            <a:off x="4709159" y="4537507"/>
-            <a:ext cx="1005840" cy="274320"/>
-          </a:xfrm>
-          <a:prstGeom prst="rect">
-            <a:avLst/>
-          </a:prstGeom>
-          <a:noFill/>
-        </p:spPr>
-        <p:txBody>
-          <a:bodyPr wrap="none">
-            <a:spAutoFit/>
-          </a:bodyPr>
-          <a:lstStyle/>
-          <a:p>
-            <a:pPr algn="ctr">
-              <a:defRPr sz="1100" b="1">
-                <a:solidFill>
-                  <a:srgbClr val="000000"/>
-                </a:solidFill>
-              </a:defRPr>
-            </a:pPr>
-            <a:r>
-              <a:t>-18.0</a:t>
-            </a:r>
-          </a:p>
-        </p:txBody>
-      </p:sp>
-      <p:sp>
-        <p:nvSpPr>
-          <p:cNvPr id="13" name="TextBox 12"/>
-          <p:cNvSpPr txBox="1"/>
-          <p:nvPr/>
-        </p:nvSpPr>
-        <p:spPr>
-          <a:xfrm>
-            <a:off x="4709159" y="6035040"/>
-            <a:ext cx="1005840" cy="457200"/>
-          </a:xfrm>
-          <a:prstGeom prst="rect">
-            <a:avLst/>
-          </a:prstGeom>
-          <a:noFill/>
-        </p:spPr>
-        <p:txBody>
-          <a:bodyPr wrap="none">
-            <a:spAutoFit/>
-          </a:bodyPr>
-          <a:lstStyle/>
-          <a:p>
-            <a:pPr algn="ctr">
-              <a:defRPr sz="1000" b="1"/>
-            </a:pPr>
-            <a:r>
-              <a:t>HW+SOP</a:t>
-            </a:r>
-          </a:p>
-        </p:txBody>
-      </p:sp>
-      <p:sp>
-        <p:nvSpPr>
-          <p:cNvPr id="14" name="Rectangle 13"/>
-          <p:cNvSpPr/>
-          <p:nvPr/>
-        </p:nvSpPr>
-        <p:spPr>
-          <a:xfrm>
-            <a:off x="5989320" y="4753143"/>
-            <a:ext cx="1005840" cy="45720"/>
-          </a:xfrm>
-          <a:prstGeom prst="rect">
-            <a:avLst/>
-          </a:prstGeom>
-          <a:solidFill>
-            <a:srgbClr val="808080"/>
-          </a:solidFill>
-          <a:ln>
-            <a:noFill/>
-          </a:ln>
-        </p:spPr>
-        <p:style>
-          <a:lnRef idx="1">
-            <a:schemeClr val="accent1"/>
-          </a:lnRef>
-          <a:fillRef idx="3">
-            <a:schemeClr val="accent1"/>
-          </a:fillRef>
-          <a:effectRef idx="2">
-            <a:schemeClr val="accent1"/>
-          </a:effectRef>
-          <a:fontRef idx="minor">
-            <a:schemeClr val="lt1"/>
-          </a:fontRef>
-        </p:style>
-        <p:txBody>
-          <a:bodyPr rtlCol="0" anchor="ctr"/>
-          <a:lstStyle/>
-          <a:p>
-            <a:pPr algn="ctr"/>
-          </a:p>
-        </p:txBody>
-      </p:sp>
-      <p:sp>
-        <p:nvSpPr>
-          <p:cNvPr id="15" name="TextBox 14"/>
-          <p:cNvSpPr txBox="1"/>
-          <p:nvPr/>
-        </p:nvSpPr>
-        <p:spPr>
-          <a:xfrm>
-            <a:off x="5989320" y="4638843"/>
-            <a:ext cx="1005840" cy="274320"/>
-          </a:xfrm>
-          <a:prstGeom prst="rect">
-            <a:avLst/>
-          </a:prstGeom>
-          <a:noFill/>
-        </p:spPr>
-        <p:txBody>
-          <a:bodyPr wrap="none">
-            <a:spAutoFit/>
-          </a:bodyPr>
-          <a:lstStyle/>
-          <a:p>
-            <a:pPr algn="ctr">
-              <a:defRPr sz="1100" b="1">
-                <a:solidFill>
-                  <a:srgbClr val="000000"/>
-                </a:solidFill>
-              </a:defRPr>
-            </a:pPr>
-            <a:r>
-              <a:t>0</a:t>
-            </a:r>
-          </a:p>
-        </p:txBody>
-      </p:sp>
-      <p:sp>
-        <p:nvSpPr>
-          <p:cNvPr id="16" name="TextBox 15"/>
-          <p:cNvSpPr txBox="1"/>
-          <p:nvPr/>
-        </p:nvSpPr>
-        <p:spPr>
-          <a:xfrm>
-            <a:off x="5989320" y="6035040"/>
-            <a:ext cx="1005840" cy="457200"/>
-          </a:xfrm>
-          <a:prstGeom prst="rect">
-            <a:avLst/>
-          </a:prstGeom>
-          <a:noFill/>
-        </p:spPr>
-        <p:txBody>
-          <a:bodyPr wrap="none">
-            <a:spAutoFit/>
-          </a:bodyPr>
-          <a:lstStyle/>
-          <a:p>
-            <a:pPr algn="ctr">
-              <a:defRPr sz="1000" b="1"/>
-            </a:pPr>
-            <a:r>
-              <a:t>RPx</a:t>
-            </a:r>
-          </a:p>
-        </p:txBody>
-      </p:sp>
-      <p:sp>
-        <p:nvSpPr>
-          <p:cNvPr id="17" name="Rectangle 16"/>
-          <p:cNvSpPr/>
-          <p:nvPr/>
-        </p:nvSpPr>
-        <p:spPr>
-          <a:xfrm>
-            <a:off x="7269480" y="4753143"/>
-            <a:ext cx="1005840" cy="1190456"/>
-          </a:xfrm>
-          <a:prstGeom prst="rect">
-            <a:avLst/>
-          </a:prstGeom>
-          <a:solidFill>
-            <a:srgbClr val="00B050"/>
-          </a:solidFill>
-          <a:ln>
-            <a:noFill/>
-          </a:ln>
-        </p:spPr>
-        <p:style>
-          <a:lnRef idx="1">
-            <a:schemeClr val="accent1"/>
-          </a:lnRef>
-          <a:fillRef idx="3">
-            <a:schemeClr val="accent1"/>
-          </a:fillRef>
-          <a:effectRef idx="2">
-            <a:schemeClr val="accent1"/>
-          </a:effectRef>
-          <a:fontRef idx="minor">
-            <a:schemeClr val="lt1"/>
-          </a:fontRef>
-        </p:style>
-        <p:txBody>
-          <a:bodyPr rtlCol="0" anchor="ctr"/>
-          <a:lstStyle/>
-          <a:p>
-            <a:pPr algn="ctr"/>
-          </a:p>
-        </p:txBody>
-      </p:sp>
-      <p:sp>
-        <p:nvSpPr>
-          <p:cNvPr id="18" name="TextBox 17"/>
-          <p:cNvSpPr txBox="1"/>
-          <p:nvPr/>
-        </p:nvSpPr>
-        <p:spPr>
-          <a:xfrm>
-            <a:off x="7269480" y="4433103"/>
-            <a:ext cx="1005840" cy="274320"/>
-          </a:xfrm>
-          <a:prstGeom prst="rect">
-            <a:avLst/>
-          </a:prstGeom>
-          <a:noFill/>
-        </p:spPr>
-        <p:txBody>
-          <a:bodyPr wrap="none">
-            <a:spAutoFit/>
-          </a:bodyPr>
-          <a:lstStyle/>
-          <a:p>
-            <a:pPr algn="ctr">
-              <a:defRPr sz="1100" b="1">
-                <a:solidFill>
-                  <a:srgbClr val="000000"/>
-                </a:solidFill>
-              </a:defRPr>
-            </a:pPr>
-            <a:r>
-              <a:t>136.9</a:t>
-            </a:r>
-          </a:p>
-        </p:txBody>
-      </p:sp>
-      <p:sp>
-        <p:nvSpPr>
-          <p:cNvPr id="19" name="TextBox 18"/>
-          <p:cNvSpPr txBox="1"/>
-          <p:nvPr/>
-        </p:nvSpPr>
-        <p:spPr>
-          <a:xfrm>
-            <a:off x="7269480" y="6035040"/>
-            <a:ext cx="1005840" cy="457200"/>
-          </a:xfrm>
-          <a:prstGeom prst="rect">
-            <a:avLst/>
-          </a:prstGeom>
-          <a:noFill/>
-        </p:spPr>
-        <p:txBody>
-          <a:bodyPr wrap="none">
-            <a:spAutoFit/>
-          </a:bodyPr>
-          <a:lstStyle/>
-          <a:p>
-            <a:pPr algn="ctr">
-              <a:defRPr sz="1000" b="1"/>
-            </a:pPr>
-            <a:r>
-              <a:t>Customer Facing</a:t>
-            </a:r>
-          </a:p>
-        </p:txBody>
-      </p:sp>
-      <p:sp>
-        <p:nvSpPr>
-          <p:cNvPr id="20" name="Rectangle 19"/>
-          <p:cNvSpPr/>
-          <p:nvPr/>
-        </p:nvSpPr>
-        <p:spPr>
-          <a:xfrm>
-            <a:off x="3154679" y="3783447"/>
-            <a:ext cx="274320" cy="18288"/>
-          </a:xfrm>
-          <a:prstGeom prst="rect">
-            <a:avLst/>
-          </a:prstGeom>
-          <a:solidFill>
-            <a:srgbClr val="808080"/>
-          </a:solidFill>
-          <a:ln>
-            <a:noFill/>
-          </a:ln>
-        </p:spPr>
-        <p:style>
-          <a:lnRef idx="1">
-            <a:schemeClr val="accent1"/>
-          </a:lnRef>
-          <a:fillRef idx="3">
-            <a:schemeClr val="accent1"/>
-          </a:fillRef>
-          <a:effectRef idx="2">
-            <a:schemeClr val="accent1"/>
-          </a:effectRef>
-          <a:fontRef idx="minor">
-            <a:schemeClr val="lt1"/>
-          </a:fontRef>
-        </p:style>
-        <p:txBody>
-          <a:bodyPr rtlCol="0" anchor="ctr"/>
-          <a:lstStyle/>
-          <a:p>
-            <a:pPr algn="ctr"/>
-          </a:p>
-        </p:txBody>
-      </p:sp>
-      <p:sp>
-        <p:nvSpPr>
-          <p:cNvPr id="21" name="Rectangle 20"/>
-          <p:cNvSpPr/>
-          <p:nvPr/>
-        </p:nvSpPr>
-        <p:spPr>
-          <a:xfrm>
-            <a:off x="4434840" y="4596191"/>
-            <a:ext cx="274320" cy="18288"/>
-          </a:xfrm>
-          <a:prstGeom prst="rect">
-            <a:avLst/>
-          </a:prstGeom>
-          <a:solidFill>
-            <a:srgbClr val="808080"/>
-          </a:solidFill>
-          <a:ln>
-            <a:noFill/>
-          </a:ln>
-        </p:spPr>
-        <p:style>
-          <a:lnRef idx="1">
-            <a:schemeClr val="accent1"/>
-          </a:lnRef>
-          <a:fillRef idx="3">
-            <a:schemeClr val="accent1"/>
-          </a:fillRef>
-          <a:effectRef idx="2">
-            <a:schemeClr val="accent1"/>
-          </a:effectRef>
-          <a:fontRef idx="minor">
-            <a:schemeClr val="lt1"/>
-          </a:fontRef>
-        </p:style>
-        <p:txBody>
-          <a:bodyPr rtlCol="0" anchor="ctr"/>
-          <a:lstStyle/>
-          <a:p>
-            <a:pPr algn="ctr"/>
-          </a:p>
-        </p:txBody>
-      </p:sp>
-      <p:sp>
-        <p:nvSpPr>
-          <p:cNvPr id="22" name="Rectangle 21"/>
-          <p:cNvSpPr/>
-          <p:nvPr/>
-        </p:nvSpPr>
-        <p:spPr>
-          <a:xfrm>
-            <a:off x="5715000" y="4753143"/>
-            <a:ext cx="274320" cy="18288"/>
-          </a:xfrm>
-          <a:prstGeom prst="rect">
-            <a:avLst/>
-          </a:prstGeom>
-          <a:solidFill>
-            <a:srgbClr val="808080"/>
-          </a:solidFill>
-          <a:ln>
-            <a:noFill/>
-          </a:ln>
-        </p:spPr>
-        <p:style>
-          <a:lnRef idx="1">
-            <a:schemeClr val="accent1"/>
-          </a:lnRef>
-          <a:fillRef idx="3">
-            <a:schemeClr val="accent1"/>
-          </a:fillRef>
-          <a:effectRef idx="2">
-            <a:schemeClr val="accent1"/>
-          </a:effectRef>
-          <a:fontRef idx="minor">
-            <a:schemeClr val="lt1"/>
-          </a:fontRef>
-        </p:style>
-        <p:txBody>
-          <a:bodyPr rtlCol="0" anchor="ctr"/>
-          <a:lstStyle/>
-          <a:p>
-            <a:pPr algn="ctr"/>
-          </a:p>
-        </p:txBody>
-      </p:sp>
-      <p:sp>
-        <p:nvSpPr>
-          <p:cNvPr id="23" name="Rectangle 22"/>
-          <p:cNvSpPr/>
-          <p:nvPr/>
-        </p:nvSpPr>
-        <p:spPr>
-          <a:xfrm>
-            <a:off x="6858000" y="1463040"/>
-            <a:ext cx="228600" cy="182880"/>
-          </a:xfrm>
-          <a:prstGeom prst="rect">
-            <a:avLst/>
-          </a:prstGeom>
-          <a:solidFill>
-            <a:srgbClr val="0070C0"/>
-          </a:solidFill>
-          <a:ln>
-            <a:noFill/>
-          </a:ln>
-        </p:spPr>
-        <p:style>
-          <a:lnRef idx="1">
-            <a:schemeClr val="accent1"/>
-          </a:lnRef>
-          <a:fillRef idx="3">
-            <a:schemeClr val="accent1"/>
-          </a:fillRef>
-          <a:effectRef idx="2">
-            <a:schemeClr val="accent1"/>
-          </a:effectRef>
-          <a:fontRef idx="minor">
-            <a:schemeClr val="lt1"/>
-          </a:fontRef>
-        </p:style>
-        <p:txBody>
-          <a:bodyPr rtlCol="0" anchor="ctr"/>
-          <a:lstStyle/>
-          <a:p>
-            <a:pPr algn="ctr"/>
-          </a:p>
-        </p:txBody>
-      </p:sp>
-      <p:sp>
-        <p:nvSpPr>
-          <p:cNvPr id="24" name="TextBox 23"/>
-          <p:cNvSpPr txBox="1"/>
-          <p:nvPr/>
-        </p:nvSpPr>
-        <p:spPr>
-          <a:xfrm>
-            <a:off x="7178040" y="1444752"/>
-            <a:ext cx="1645920" cy="228600"/>
-          </a:xfrm>
-          <a:prstGeom prst="rect">
-            <a:avLst/>
-          </a:prstGeom>
-          <a:noFill/>
-        </p:spPr>
-        <p:txBody>
-          <a:bodyPr wrap="none">
-            <a:spAutoFit/>
-          </a:bodyPr>
-          <a:lstStyle/>
-          <a:p>
-            <a:pPr>
-              <a:defRPr sz="900"/>
-            </a:pPr>
-            <a:r>
-              <a:t>Total cDPM</a:t>
-            </a:r>
-          </a:p>
-        </p:txBody>
-      </p:sp>
-      <p:sp>
-        <p:nvSpPr>
-          <p:cNvPr id="25" name="Rectangle 24"/>
-          <p:cNvSpPr/>
-          <p:nvPr/>
-        </p:nvSpPr>
-        <p:spPr>
-          <a:xfrm>
-            <a:off x="6858000" y="1783080"/>
-            <a:ext cx="228600" cy="182880"/>
-          </a:xfrm>
-          <a:prstGeom prst="rect">
-            <a:avLst/>
-          </a:prstGeom>
-          <a:solidFill>
-            <a:srgbClr val="FF6347"/>
-          </a:solidFill>
-          <a:ln>
-            <a:noFill/>
-          </a:ln>
-        </p:spPr>
-        <p:style>
-          <a:lnRef idx="1">
-            <a:schemeClr val="accent1"/>
-          </a:lnRef>
-          <a:fillRef idx="3">
-            <a:schemeClr val="accent1"/>
-          </a:fillRef>
-          <a:effectRef idx="2">
-            <a:schemeClr val="accent1"/>
-          </a:effectRef>
-          <a:fontRef idx="minor">
-            <a:schemeClr val="lt1"/>
-          </a:fontRef>
-        </p:style>
-        <p:txBody>
-          <a:bodyPr rtlCol="0" anchor="ctr"/>
-          <a:lstStyle/>
-          <a:p>
-            <a:pPr algn="ctr"/>
-          </a:p>
-        </p:txBody>
-      </p:sp>
-      <p:sp>
-        <p:nvSpPr>
-          <p:cNvPr id="26" name="TextBox 25"/>
-          <p:cNvSpPr txBox="1"/>
-          <p:nvPr/>
-        </p:nvSpPr>
-        <p:spPr>
-          <a:xfrm>
-            <a:off x="7178040" y="1764792"/>
-            <a:ext cx="1645920" cy="228600"/>
-          </a:xfrm>
-          <a:prstGeom prst="rect">
-            <a:avLst/>
-          </a:prstGeom>
-          <a:noFill/>
-        </p:spPr>
-        <p:txBody>
-          <a:bodyPr wrap="none">
-            <a:spAutoFit/>
-          </a:bodyPr>
-          <a:lstStyle/>
-          <a:p>
-            <a:pPr>
-              <a:defRPr sz="900"/>
-            </a:pPr>
-            <a:r>
-              <a:t>Recovery</a:t>
-            </a:r>
-          </a:p>
-        </p:txBody>
-      </p:sp>
-      <p:sp>
-        <p:nvSpPr>
-          <p:cNvPr id="27" name="Rectangle 26"/>
-          <p:cNvSpPr/>
-          <p:nvPr/>
-        </p:nvSpPr>
-        <p:spPr>
-          <a:xfrm>
-            <a:off x="6858000" y="2103120"/>
-            <a:ext cx="228600" cy="182880"/>
-          </a:xfrm>
-          <a:prstGeom prst="rect">
-            <a:avLst/>
-          </a:prstGeom>
-          <a:solidFill>
-            <a:srgbClr val="00B050"/>
-          </a:solidFill>
-          <a:ln>
-            <a:noFill/>
-          </a:ln>
-        </p:spPr>
-        <p:style>
-          <a:lnRef idx="1">
-            <a:schemeClr val="accent1"/>
-          </a:lnRef>
-          <a:fillRef idx="3">
-            <a:schemeClr val="accent1"/>
-          </a:fillRef>
-          <a:effectRef idx="2">
-            <a:schemeClr val="accent1"/>
-          </a:effectRef>
-          <a:fontRef idx="minor">
-            <a:schemeClr val="lt1"/>
-          </a:fontRef>
-        </p:style>
-        <p:txBody>
-          <a:bodyPr rtlCol="0" anchor="ctr"/>
-          <a:lstStyle/>
-          <a:p>
-            <a:pPr algn="ctr"/>
-          </a:p>
-        </p:txBody>
-      </p:sp>
-      <p:sp>
-        <p:nvSpPr>
-          <p:cNvPr id="28" name="TextBox 27"/>
-          <p:cNvSpPr txBox="1"/>
-          <p:nvPr/>
-        </p:nvSpPr>
-        <p:spPr>
-          <a:xfrm>
-            <a:off x="7178040" y="2084831"/>
-            <a:ext cx="1645920" cy="228600"/>
-          </a:xfrm>
-          <a:prstGeom prst="rect">
-            <a:avLst/>
-          </a:prstGeom>
-          <a:noFill/>
-        </p:spPr>
-        <p:txBody>
-          <a:bodyPr wrap="none">
-            <a:spAutoFit/>
-          </a:bodyPr>
-          <a:lstStyle/>
-          <a:p>
-            <a:pPr>
-              <a:defRPr sz="900"/>
-            </a:pPr>
-            <a:r>
-              <a:t>Customer-Facing</a:t>
-            </a:r>
-          </a:p>
-        </p:txBody>
-      </p:sp>
-      <p:sp>
-        <p:nvSpPr>
-          <p:cNvPr id="29" name="TextBox 28"/>
-          <p:cNvSpPr txBox="1"/>
-          <p:nvPr/>
-        </p:nvSpPr>
-        <p:spPr>
-          <a:xfrm>
-            <a:off x="457200" y="6126480"/>
-            <a:ext cx="8229600" cy="365760"/>
-          </a:xfrm>
-          <a:prstGeom prst="rect">
-            <a:avLst/>
-          </a:prstGeom>
-          <a:noFill/>
-        </p:spPr>
-        <p:txBody>
-          <a:bodyPr wrap="none">
-            <a:spAutoFit/>
-          </a:bodyPr>
-          <a:lstStyle/>
-          <a:p>
-            <a:pPr algn="ctr">
-              <a:defRPr sz="1200" b="1">
-                <a:solidFill>
-                  <a:srgbClr val="0070C0"/>
-                </a:solidFill>
-              </a:defRPr>
-            </a:pPr>
-            <a:r>
-              <a:t>Total Recovery: 71.4% (341.1 DPM recovered)</a:t>
-            </a:r>
-          </a:p>
-        </p:txBody>
-      </p:sp>
-    </p:spTree>
-  </p:cSld>
-  <p:clrMapOvr>
-    <a:masterClrMapping/>
-  </p:clrMapOvr>
-</p:sld>
-</file>
-
-<file path=ppt/slides/slide9.xml><?xml version="1.0" encoding="utf-8"?>
-<p:sld xmlns:a="http://schemas.openxmlformats.org/drawingml/2006/main" xmlns:p="http://schemas.openxmlformats.org/presentationml/2006/main" xmlns:r="http://schemas.openxmlformats.org/officeDocument/2006/relationships">
-  <p:cSld>
-    <p:spTree>
-      <p:nvGrpSpPr>
-        <p:cNvPr id="1" name=""/>
-        <p:cNvGrpSpPr/>
-        <p:nvPr/>
-      </p:nvGrpSpPr>
-      <p:grpSpPr/>
-      <p:sp>
-        <p:nvSpPr>
-          <p:cNvPr id="2" name="Rectangle 1"/>
-          <p:cNvSpPr/>
-          <p:nvPr/>
-        </p:nvSpPr>
-        <p:spPr>
-          <a:xfrm>
-            <a:off x="0" y="0"/>
-            <a:ext cx="12191695" cy="822960"/>
-          </a:xfrm>
-          <a:prstGeom prst="rect">
-            <a:avLst/>
-          </a:prstGeom>
-          <a:solidFill>
-            <a:srgbClr val="003366"/>
-          </a:solidFill>
-          <a:ln>
-            <a:noFill/>
-          </a:ln>
-        </p:spPr>
-        <p:style>
-          <a:lnRef idx="1">
-            <a:schemeClr val="accent1"/>
-          </a:lnRef>
-          <a:fillRef idx="3">
-            <a:schemeClr val="accent1"/>
-          </a:fillRef>
-          <a:effectRef idx="2">
-            <a:schemeClr val="accent1"/>
-          </a:effectRef>
-          <a:fontRef idx="minor">
-            <a:schemeClr val="lt1"/>
-          </a:fontRef>
-        </p:style>
-        <p:txBody>
-          <a:bodyPr rtlCol="0" anchor="ctr"/>
-          <a:lstStyle/>
-          <a:p>
-            <a:pPr algn="ctr"/>
-          </a:p>
-        </p:txBody>
-      </p:sp>
-      <p:sp>
-        <p:nvSpPr>
-          <p:cNvPr id="3" name="TextBox 2"/>
-          <p:cNvSpPr txBox="1"/>
-          <p:nvPr/>
-        </p:nvSpPr>
-        <p:spPr>
-          <a:xfrm>
-            <a:off x="274320" y="182880"/>
-            <a:ext cx="11430000" cy="548640"/>
+            <a:off x="457200" y="228600"/>
+            <a:ext cx="10972800" cy="548640"/>
           </a:xfrm>
           <a:prstGeom prst="rect">
             <a:avLst/>
@@ -6664,21 +4440,491 @@
               </a:defRPr>
             </a:pPr>
             <a:r>
-              <a:t>Appendix: Data Sources &amp; Commands</a:t>
-            </a:r>
-          </a:p>
-        </p:txBody>
-      </p:sp>
-      <p:sp>
-        <p:nvSpPr>
-          <p:cNvPr id="4" name="TextBox 3"/>
+              <a:t>Recovery by Test Step</a:t>
+            </a:r>
+          </a:p>
+        </p:txBody>
+      </p:sp>
+      <p:graphicFrame>
+        <p:nvGraphicFramePr>
+          <p:cNvPr id="4" name="Table 3"/>
+          <p:cNvGraphicFramePr>
+            <a:graphicFrameLocks noGrp="1"/>
+          </p:cNvGraphicFramePr>
+          <p:nvPr/>
+        </p:nvGraphicFramePr>
+        <p:xfrm>
+          <a:off x="457200" y="1371600"/>
+          <a:ext cx="11277295" cy="1828800"/>
+        </p:xfrm>
+        <a:graphic>
+          <a:graphicData uri="http://schemas.openxmlformats.org/drawingml/2006/table">
+            <a:tbl>
+              <a:tblPr firstRow="1" bandRow="1">
+                <a:tableStyleId>{5C22544A-7EE6-4342-B048-85BDC9FD1C3A}</a:tableStyleId>
+              </a:tblPr>
+              <a:tblGrid>
+                <a:gridCol w="1879549"/>
+                <a:gridCol w="1879549"/>
+                <a:gridCol w="1879549"/>
+                <a:gridCol w="1879549"/>
+                <a:gridCol w="1879549"/>
+                <a:gridCol w="1879550"/>
+              </a:tblGrid>
+              <a:tr h="457200">
+                <a:tc>
+                  <a:txBody>
+                    <a:bodyPr/>
+                    <a:lstStyle/>
+                    <a:p>
+                      <a:pPr>
+                        <a:defRPr b="1" sz="1200">
+                          <a:solidFill>
+                            <a:srgbClr val="FFFFFF"/>
+                          </a:solidFill>
+                        </a:defRPr>
+                      </a:pPr>
+                      <a:r>
+                        <a:t>Step</a:t>
+                      </a:r>
+                    </a:p>
+                  </a:txBody>
+                  <a:tcPr>
+                    <a:solidFill>
+                      <a:srgbClr val="1A237E"/>
+                    </a:solidFill>
+                  </a:tcPr>
+                </a:tc>
+                <a:tc>
+                  <a:txBody>
+                    <a:bodyPr/>
+                    <a:lstStyle/>
+                    <a:p>
+                      <a:pPr algn="ctr">
+                        <a:defRPr b="1" sz="1200">
+                          <a:solidFill>
+                            <a:srgbClr val="FFFFFF"/>
+                          </a:solidFill>
+                        </a:defRPr>
+                      </a:pPr>
+                      <a:r>
+                        <a:t>Total DPM</a:t>
+                      </a:r>
+                    </a:p>
+                  </a:txBody>
+                  <a:tcPr>
+                    <a:solidFill>
+                      <a:srgbClr val="1A237E"/>
+                    </a:solidFill>
+                  </a:tcPr>
+                </a:tc>
+                <a:tc>
+                  <a:txBody>
+                    <a:bodyPr/>
+                    <a:lstStyle/>
+                    <a:p>
+                      <a:pPr algn="ctr">
+                        <a:defRPr b="1" sz="1200">
+                          <a:solidFill>
+                            <a:srgbClr val="FFFFFF"/>
+                          </a:solidFill>
+                        </a:defRPr>
+                      </a:pPr>
+                      <a:r>
+                        <a:t>BIOS</a:t>
+                      </a:r>
+                    </a:p>
+                  </a:txBody>
+                  <a:tcPr>
+                    <a:solidFill>
+                      <a:srgbClr val="1A237E"/>
+                    </a:solidFill>
+                  </a:tcPr>
+                </a:tc>
+                <a:tc>
+                  <a:txBody>
+                    <a:bodyPr/>
+                    <a:lstStyle/>
+                    <a:p>
+                      <a:pPr algn="ctr">
+                        <a:defRPr b="1" sz="1200">
+                          <a:solidFill>
+                            <a:srgbClr val="FFFFFF"/>
+                          </a:solidFill>
+                        </a:defRPr>
+                      </a:pPr>
+                      <a:r>
+                        <a:t>HW+SOP</a:t>
+                      </a:r>
+                    </a:p>
+                  </a:txBody>
+                  <a:tcPr>
+                    <a:solidFill>
+                      <a:srgbClr val="1A237E"/>
+                    </a:solidFill>
+                  </a:tcPr>
+                </a:tc>
+                <a:tc>
+                  <a:txBody>
+                    <a:bodyPr/>
+                    <a:lstStyle/>
+                    <a:p>
+                      <a:pPr algn="ctr">
+                        <a:defRPr b="1" sz="1200">
+                          <a:solidFill>
+                            <a:srgbClr val="FFFFFF"/>
+                          </a:solidFill>
+                        </a:defRPr>
+                      </a:pPr>
+                      <a:r>
+                        <a:t>Recoverable</a:t>
+                      </a:r>
+                    </a:p>
+                  </a:txBody>
+                  <a:tcPr>
+                    <a:solidFill>
+                      <a:srgbClr val="1A237E"/>
+                    </a:solidFill>
+                  </a:tcPr>
+                </a:tc>
+                <a:tc>
+                  <a:txBody>
+                    <a:bodyPr/>
+                    <a:lstStyle/>
+                    <a:p>
+                      <a:pPr algn="ctr">
+                        <a:defRPr b="1" sz="1200">
+                          <a:solidFill>
+                            <a:srgbClr val="FFFFFF"/>
+                          </a:solidFill>
+                        </a:defRPr>
+                      </a:pPr>
+                      <a:r>
+                        <a:t>Remaining</a:t>
+                      </a:r>
+                    </a:p>
+                  </a:txBody>
+                  <a:tcPr>
+                    <a:solidFill>
+                      <a:srgbClr val="1A237E"/>
+                    </a:solidFill>
+                  </a:tcPr>
+                </a:tc>
+              </a:tr>
+              <a:tr h="457200">
+                <a:tc>
+                  <a:txBody>
+                    <a:bodyPr/>
+                    <a:lstStyle/>
+                    <a:p>
+                      <a:pPr>
+                        <a:defRPr sz="1100"/>
+                      </a:pPr>
+                      <a:r>
+                        <a:t>HMB1</a:t>
+                      </a:r>
+                    </a:p>
+                  </a:txBody>
+                  <a:tcPr/>
+                </a:tc>
+                <a:tc>
+                  <a:txBody>
+                    <a:bodyPr/>
+                    <a:lstStyle/>
+                    <a:p>
+                      <a:pPr algn="ctr">
+                        <a:defRPr sz="1100"/>
+                      </a:pPr>
+                      <a:r>
+                        <a:t>287.1</a:t>
+                      </a:r>
+                    </a:p>
+                  </a:txBody>
+                  <a:tcPr/>
+                </a:tc>
+                <a:tc>
+                  <a:txBody>
+                    <a:bodyPr/>
+                    <a:lstStyle/>
+                    <a:p>
+                      <a:pPr algn="ctr">
+                        <a:defRPr sz="1100"/>
+                      </a:pPr>
+                      <a:r>
+                        <a:t>191.8 (66.8%)</a:t>
+                      </a:r>
+                    </a:p>
+                  </a:txBody>
+                  <a:tcPr/>
+                </a:tc>
+                <a:tc>
+                  <a:txBody>
+                    <a:bodyPr/>
+                    <a:lstStyle/>
+                    <a:p>
+                      <a:pPr algn="ctr">
+                        <a:defRPr sz="1100"/>
+                      </a:pPr>
+                      <a:r>
+                        <a:t>11.5 (4.0%)</a:t>
+                      </a:r>
+                    </a:p>
+                  </a:txBody>
+                  <a:tcPr/>
+                </a:tc>
+                <a:tc>
+                  <a:txBody>
+                    <a:bodyPr/>
+                    <a:lstStyle/>
+                    <a:p>
+                      <a:pPr algn="ctr">
+                        <a:defRPr sz="1100"/>
+                      </a:pPr>
+                      <a:r>
+                        <a:t>203.3 (70.8%)</a:t>
+                      </a:r>
+                    </a:p>
+                  </a:txBody>
+                  <a:tcPr/>
+                </a:tc>
+                <a:tc>
+                  <a:txBody>
+                    <a:bodyPr/>
+                    <a:lstStyle/>
+                    <a:p>
+                      <a:pPr algn="ctr">
+                        <a:defRPr sz="1100"/>
+                      </a:pPr>
+                      <a:r>
+                        <a:t>83.8 (29.2%)</a:t>
+                      </a:r>
+                    </a:p>
+                  </a:txBody>
+                  <a:tcPr/>
+                </a:tc>
+              </a:tr>
+              <a:tr h="457200">
+                <a:tc>
+                  <a:txBody>
+                    <a:bodyPr/>
+                    <a:lstStyle/>
+                    <a:p>
+                      <a:pPr>
+                        <a:defRPr sz="1100"/>
+                      </a:pPr>
+                      <a:r>
+                        <a:t>QMON</a:t>
+                      </a:r>
+                    </a:p>
+                  </a:txBody>
+                  <a:tcPr/>
+                </a:tc>
+                <a:tc>
+                  <a:txBody>
+                    <a:bodyPr/>
+                    <a:lstStyle/>
+                    <a:p>
+                      <a:pPr algn="ctr">
+                        <a:defRPr sz="1100"/>
+                      </a:pPr>
+                      <a:r>
+                        <a:t>190.9</a:t>
+                      </a:r>
+                    </a:p>
+                  </a:txBody>
+                  <a:tcPr/>
+                </a:tc>
+                <a:tc>
+                  <a:txBody>
+                    <a:bodyPr/>
+                    <a:lstStyle/>
+                    <a:p>
+                      <a:pPr algn="ctr">
+                        <a:defRPr sz="1100"/>
+                      </a:pPr>
+                      <a:r>
+                        <a:t>130.3 (68.3%)</a:t>
+                      </a:r>
+                    </a:p>
+                  </a:txBody>
+                  <a:tcPr/>
+                </a:tc>
+                <a:tc>
+                  <a:txBody>
+                    <a:bodyPr/>
+                    <a:lstStyle/>
+                    <a:p>
+                      <a:pPr algn="ctr">
+                        <a:defRPr sz="1100"/>
+                      </a:pPr>
+                      <a:r>
+                        <a:t>7.8 (4.1%)</a:t>
+                      </a:r>
+                    </a:p>
+                  </a:txBody>
+                  <a:tcPr/>
+                </a:tc>
+                <a:tc>
+                  <a:txBody>
+                    <a:bodyPr/>
+                    <a:lstStyle/>
+                    <a:p>
+                      <a:pPr algn="ctr">
+                        <a:defRPr sz="1100"/>
+                      </a:pPr>
+                      <a:r>
+                        <a:t>138.1 (72.3%)</a:t>
+                      </a:r>
+                    </a:p>
+                  </a:txBody>
+                  <a:tcPr/>
+                </a:tc>
+                <a:tc>
+                  <a:txBody>
+                    <a:bodyPr/>
+                    <a:lstStyle/>
+                    <a:p>
+                      <a:pPr algn="ctr">
+                        <a:defRPr sz="1100"/>
+                      </a:pPr>
+                      <a:r>
+                        <a:t>52.8 (27.7%)</a:t>
+                      </a:r>
+                    </a:p>
+                  </a:txBody>
+                  <a:tcPr/>
+                </a:tc>
+              </a:tr>
+              <a:tr h="457200">
+                <a:tc>
+                  <a:txBody>
+                    <a:bodyPr/>
+                    <a:lstStyle/>
+                    <a:p>
+                      <a:pPr>
+                        <a:defRPr b="1" sz="1100"/>
+                      </a:pPr>
+                      <a:r>
+                        <a:t>SLT Total</a:t>
+                      </a:r>
+                    </a:p>
+                  </a:txBody>
+                  <a:tcPr>
+                    <a:solidFill>
+                      <a:srgbClr val="E8F5E9"/>
+                    </a:solidFill>
+                  </a:tcPr>
+                </a:tc>
+                <a:tc>
+                  <a:txBody>
+                    <a:bodyPr/>
+                    <a:lstStyle/>
+                    <a:p>
+                      <a:pPr algn="ctr">
+                        <a:defRPr b="1" sz="1100"/>
+                      </a:pPr>
+                      <a:r>
+                        <a:t>478.0</a:t>
+                      </a:r>
+                    </a:p>
+                  </a:txBody>
+                  <a:tcPr>
+                    <a:solidFill>
+                      <a:srgbClr val="E8F5E9"/>
+                    </a:solidFill>
+                  </a:tcPr>
+                </a:tc>
+                <a:tc>
+                  <a:txBody>
+                    <a:bodyPr/>
+                    <a:lstStyle/>
+                    <a:p>
+                      <a:pPr algn="ctr">
+                        <a:defRPr b="1" sz="1100"/>
+                      </a:pPr>
+                      <a:r>
+                        <a:t>322.1 (67.4%)</a:t>
+                      </a:r>
+                    </a:p>
+                  </a:txBody>
+                  <a:tcPr>
+                    <a:solidFill>
+                      <a:srgbClr val="E8F5E9"/>
+                    </a:solidFill>
+                  </a:tcPr>
+                </a:tc>
+                <a:tc>
+                  <a:txBody>
+                    <a:bodyPr/>
+                    <a:lstStyle/>
+                    <a:p>
+                      <a:pPr algn="ctr">
+                        <a:defRPr b="1" sz="1100"/>
+                      </a:pPr>
+                      <a:r>
+                        <a:t>19.3 (4.0%)</a:t>
+                      </a:r>
+                    </a:p>
+                  </a:txBody>
+                  <a:tcPr>
+                    <a:solidFill>
+                      <a:srgbClr val="E8F5E9"/>
+                    </a:solidFill>
+                  </a:tcPr>
+                </a:tc>
+                <a:tc>
+                  <a:txBody>
+                    <a:bodyPr/>
+                    <a:lstStyle/>
+                    <a:p>
+                      <a:pPr algn="ctr">
+                        <a:defRPr b="1" sz="1100"/>
+                      </a:pPr>
+                      <a:r>
+                        <a:t>341.4 (71.4%)</a:t>
+                      </a:r>
+                    </a:p>
+                  </a:txBody>
+                  <a:tcPr>
+                    <a:solidFill>
+                      <a:srgbClr val="E8F5E9"/>
+                    </a:solidFill>
+                  </a:tcPr>
+                </a:tc>
+                <a:tc>
+                  <a:txBody>
+                    <a:bodyPr/>
+                    <a:lstStyle/>
+                    <a:p>
+                      <a:pPr algn="ctr">
+                        <a:defRPr b="1" sz="1100"/>
+                      </a:pPr>
+                      <a:r>
+                        <a:t>136.6 (28.6%)</a:t>
+                      </a:r>
+                    </a:p>
+                  </a:txBody>
+                  <a:tcPr>
+                    <a:solidFill>
+                      <a:srgbClr val="E8F5E9"/>
+                    </a:solidFill>
+                  </a:tcPr>
+                </a:tc>
+              </a:tr>
+            </a:tbl>
+          </a:graphicData>
+        </a:graphic>
+      </p:graphicFrame>
+      <p:sp>
+        <p:nvSpPr>
+          <p:cNvPr id="5" name="TextBox 4"/>
           <p:cNvSpPr txBox="1"/>
           <p:nvPr/>
         </p:nvSpPr>
         <p:spPr>
           <a:xfrm>
-            <a:off x="274320" y="914400"/>
-            <a:ext cx="11612880" cy="5669280"/>
+            <a:off x="457200" y="3657600"/>
+            <a:ext cx="10972800" cy="2286000"/>
           </a:xfrm>
           <a:prstGeom prst="rect">
             <a:avLst/>
@@ -6692,90 +4938,34 @@
           <a:lstStyle/>
           <a:p>
             <a:pPr>
-              <a:defRPr sz="1100">
-                <a:latin typeface="Consolas"/>
-              </a:defRPr>
+              <a:defRPr sz="1600" b="1"/>
             </a:pPr>
             <a:r>
-              <a:t>Data Collection:</a:t>
-            </a:r>
-            <a:br/>
-            <a:br/>
-            <a:r>
-              <a:t>1. Unique Failing MSNs (Numerator):</a:t>
-            </a:r>
-            <a:br/>
-            <a:r>
-              <a:t>   mtsums -dbase=y6cp -step={step} -module_form_factor=socamm2 \</a:t>
-            </a:r>
-            <a:br/>
-            <a:r>
-              <a:t>       -module_speed=7500MTPS -mfg_workweek=202608,...,202617 +stdf +msnag</a:t>
-            </a:r>
-            <a:br/>
-            <a:br/>
-            <a:r>
-              <a:t>2. Total FID UIN (Denominator):</a:t>
-            </a:r>
-            <a:br/>
-            <a:r>
-              <a:t>   mtsums -dbase=y6cp -step={step} -module_form_factor=socamm2 \</a:t>
-            </a:r>
-            <a:br/>
-            <a:r>
-              <a:t>       -module_speed=7500MTPS -mfg_workweek=202608,...,202617 +stdf +fidag</a:t>
-            </a:r>
-            <a:br/>
-            <a:br/>
-            <a:r>
-              <a:t>3. FAILCRAWLER Breakdown:</a:t>
-            </a:r>
-            <a:br/>
-            <a:r>
-              <a:t>   mtsums ... +stdf +fm +fc</a:t>
-            </a:r>
-            <a:br/>
-            <a:br/>
-            <a:r>
-              <a:t>4. MSN_STATUS × FAILCRAWLER Correlation:</a:t>
-            </a:r>
-            <a:br/>
-            <a:r>
-              <a:t>   mtsums ... +stdf +msnag -format=/msn_status,failcrawler/</a:t>
-            </a:r>
-            <a:br/>
-            <a:br/>
-            <a:r>
-              <a:t>5. RPx Verification:</a:t>
-            </a:r>
-            <a:br/>
-            <a:r>
-              <a:t>   /home/nmewes/Y6CP_FA/socamm_false_miscompare.py --sums {slash_paths}</a:t>
-            </a:r>
-            <a:br/>
-            <a:r>
-              <a:t>   Result: 0% false fail rate verified</a:t>
-            </a:r>
-            <a:br/>
-            <a:br/>
-            <a:r>
-              <a:t>Data Scope:</a:t>
-            </a:r>
-            <a:br/>
-            <a:r>
-              <a:t>• Product: SOCAMM2 7500MTPS</a:t>
-            </a:r>
-            <a:br/>
-            <a:r>
-              <a:t>• Period: WW202606-202615 (10 weeks cumulative)</a:t>
-            </a:r>
-            <a:br/>
-            <a:r>
-              <a:t>• Steps: HMB1, QMON</a:t>
-            </a:r>
-            <a:br/>
-            <a:r>
-              <a:t>• Database: y6cp</a:t>
+              <a:t>Key Takeaways:</a:t>
+            </a:r>
+          </a:p>
+          <a:p>
+            <a:pPr>
+              <a:defRPr sz="1400"/>
+            </a:pPr>
+            <a:r>
+              <a:t>• BIOS fixes (combined) account for 67.4% of total SLT DPM</a:t>
+            </a:r>
+          </a:p>
+          <a:p>
+            <a:pPr>
+              <a:defRPr sz="1400"/>
+            </a:pPr>
+            <a:r>
+              <a:t>• 71.4% of failures are recoverable through BIOS + HW+SOP improvements</a:t>
+            </a:r>
+          </a:p>
+          <a:p>
+            <a:pPr>
+              <a:defRPr sz="1400"/>
+            </a:pPr>
+            <a:r>
+              <a:t>• Customer-facing DPM reduces from 478.0 to 136.6 after recovery</a:t>
             </a:r>
           </a:p>
         </p:txBody>

</xml_diff>